<commit_message>
Simplify terminal dark presentation - remove clutter
Changes:
• Removed macOS-style title bar (traffic lights, window chrome)
• Removed borders around slides
• Changed font from Menlo to 'Meslo Nerd Font'
• Title slide: cleaner layout
  - No command prompt line
  - No status bar at bottom
  - Just P10k top line: ╭─  mot@rs1-c724  ~/presentation  master ⚡
• Content slides: keep status bar for context
• Simplified overall - less busy, more focus on content

Result: Much cleaner, more professional terminal aesthetic.
</commit_message>
<xml_diff>
--- a/presentation/template_terminal_enhanced.pptx
+++ b/presentation/template_terminal_enhanced.pptx
@@ -3101,358 +3101,14 @@
       <p:grpSpPr/>
       <p:sp>
         <p:nvSpPr>
-          <p:cNvPr id="2" name="Rectangle 1"/>
-          <p:cNvSpPr/>
+          <p:cNvPr id="2" name="TextBox 1"/>
+          <p:cNvSpPr txBox="1"/>
           <p:nvPr/>
         </p:nvSpPr>
         <p:spPr>
           <a:xfrm>
-            <a:off x="0" y="0"/>
-            <a:ext cx="9144000" cy="45720"/>
-          </a:xfrm>
-          <a:prstGeom prst="rect">
-            <a:avLst/>
-          </a:prstGeom>
-          <a:solidFill>
-            <a:srgbClr val="30363D"/>
-          </a:solidFill>
-          <a:ln>
-            <a:noFill/>
-          </a:ln>
-        </p:spPr>
-        <p:style>
-          <a:lnRef idx="1">
-            <a:schemeClr val="accent1"/>
-          </a:lnRef>
-          <a:fillRef idx="3">
-            <a:schemeClr val="accent1"/>
-          </a:fillRef>
-          <a:effectRef idx="2">
-            <a:schemeClr val="accent1"/>
-          </a:effectRef>
-          <a:fontRef idx="minor">
-            <a:schemeClr val="lt1"/>
-          </a:fontRef>
-        </p:style>
-        <p:txBody>
-          <a:bodyPr rtlCol="0" anchor="ctr"/>
-          <a:lstStyle/>
-          <a:p>
-            <a:pPr algn="ctr"/>
-          </a:p>
-        </p:txBody>
-      </p:sp>
-      <p:sp>
-        <p:nvSpPr>
-          <p:cNvPr id="3" name="Rectangle 2"/>
-          <p:cNvSpPr/>
-          <p:nvPr/>
-        </p:nvSpPr>
-        <p:spPr>
-          <a:xfrm>
-            <a:off x="0" y="6812280"/>
-            <a:ext cx="9144000" cy="45720"/>
-          </a:xfrm>
-          <a:prstGeom prst="rect">
-            <a:avLst/>
-          </a:prstGeom>
-          <a:solidFill>
-            <a:srgbClr val="30363D"/>
-          </a:solidFill>
-          <a:ln>
-            <a:noFill/>
-          </a:ln>
-        </p:spPr>
-        <p:style>
-          <a:lnRef idx="1">
-            <a:schemeClr val="accent1"/>
-          </a:lnRef>
-          <a:fillRef idx="3">
-            <a:schemeClr val="accent1"/>
-          </a:fillRef>
-          <a:effectRef idx="2">
-            <a:schemeClr val="accent1"/>
-          </a:effectRef>
-          <a:fontRef idx="minor">
-            <a:schemeClr val="lt1"/>
-          </a:fontRef>
-        </p:style>
-        <p:txBody>
-          <a:bodyPr rtlCol="0" anchor="ctr"/>
-          <a:lstStyle/>
-          <a:p>
-            <a:pPr algn="ctr"/>
-          </a:p>
-        </p:txBody>
-      </p:sp>
-      <p:sp>
-        <p:nvSpPr>
-          <p:cNvPr id="4" name="Rectangle 3"/>
-          <p:cNvSpPr/>
-          <p:nvPr/>
-        </p:nvSpPr>
-        <p:spPr>
-          <a:xfrm>
-            <a:off x="0" y="0"/>
-            <a:ext cx="45720" cy="6858000"/>
-          </a:xfrm>
-          <a:prstGeom prst="rect">
-            <a:avLst/>
-          </a:prstGeom>
-          <a:solidFill>
-            <a:srgbClr val="30363D"/>
-          </a:solidFill>
-          <a:ln>
-            <a:noFill/>
-          </a:ln>
-        </p:spPr>
-        <p:style>
-          <a:lnRef idx="1">
-            <a:schemeClr val="accent1"/>
-          </a:lnRef>
-          <a:fillRef idx="3">
-            <a:schemeClr val="accent1"/>
-          </a:fillRef>
-          <a:effectRef idx="2">
-            <a:schemeClr val="accent1"/>
-          </a:effectRef>
-          <a:fontRef idx="minor">
-            <a:schemeClr val="lt1"/>
-          </a:fontRef>
-        </p:style>
-        <p:txBody>
-          <a:bodyPr rtlCol="0" anchor="ctr"/>
-          <a:lstStyle/>
-          <a:p>
-            <a:pPr algn="ctr"/>
-          </a:p>
-        </p:txBody>
-      </p:sp>
-      <p:sp>
-        <p:nvSpPr>
-          <p:cNvPr id="5" name="Rectangle 4"/>
-          <p:cNvSpPr/>
-          <p:nvPr/>
-        </p:nvSpPr>
-        <p:spPr>
-          <a:xfrm>
-            <a:off x="9098280" y="0"/>
-            <a:ext cx="45720" cy="6858000"/>
-          </a:xfrm>
-          <a:prstGeom prst="rect">
-            <a:avLst/>
-          </a:prstGeom>
-          <a:solidFill>
-            <a:srgbClr val="30363D"/>
-          </a:solidFill>
-          <a:ln>
-            <a:noFill/>
-          </a:ln>
-        </p:spPr>
-        <p:style>
-          <a:lnRef idx="1">
-            <a:schemeClr val="accent1"/>
-          </a:lnRef>
-          <a:fillRef idx="3">
-            <a:schemeClr val="accent1"/>
-          </a:fillRef>
-          <a:effectRef idx="2">
-            <a:schemeClr val="accent1"/>
-          </a:effectRef>
-          <a:fontRef idx="minor">
-            <a:schemeClr val="lt1"/>
-          </a:fontRef>
-        </p:style>
-        <p:txBody>
-          <a:bodyPr rtlCol="0" anchor="ctr"/>
-          <a:lstStyle/>
-          <a:p>
-            <a:pPr algn="ctr"/>
-          </a:p>
-        </p:txBody>
-      </p:sp>
-      <p:sp>
-        <p:nvSpPr>
-          <p:cNvPr id="6" name="Rectangle 5"/>
-          <p:cNvSpPr/>
-          <p:nvPr/>
-        </p:nvSpPr>
-        <p:spPr>
-          <a:xfrm>
-            <a:off x="45720" y="73152"/>
-            <a:ext cx="9052560" cy="228600"/>
-          </a:xfrm>
-          <a:prstGeom prst="rect">
-            <a:avLst/>
-          </a:prstGeom>
-          <a:solidFill>
-            <a:srgbClr val="161B22"/>
-          </a:solidFill>
-          <a:ln>
-            <a:noFill/>
-          </a:ln>
-        </p:spPr>
-        <p:style>
-          <a:lnRef idx="1">
-            <a:schemeClr val="accent1"/>
-          </a:lnRef>
-          <a:fillRef idx="3">
-            <a:schemeClr val="accent1"/>
-          </a:fillRef>
-          <a:effectRef idx="2">
-            <a:schemeClr val="accent1"/>
-          </a:effectRef>
-          <a:fontRef idx="minor">
-            <a:schemeClr val="lt1"/>
-          </a:fontRef>
-        </p:style>
-        <p:txBody>
-          <a:bodyPr rtlCol="0" anchor="ctr"/>
-          <a:lstStyle/>
-          <a:p>
-            <a:pPr algn="ctr"/>
-          </a:p>
-        </p:txBody>
-      </p:sp>
-      <p:sp>
-        <p:nvSpPr>
-          <p:cNvPr id="7" name="Oval 6"/>
-          <p:cNvSpPr/>
-          <p:nvPr/>
-        </p:nvSpPr>
-        <p:spPr>
-          <a:xfrm>
-            <a:off x="137160" y="128016"/>
-            <a:ext cx="54864" cy="54864"/>
-          </a:xfrm>
-          <a:prstGeom prst="ellipse">
-            <a:avLst/>
-          </a:prstGeom>
-          <a:solidFill>
-            <a:srgbClr val="F85149"/>
-          </a:solidFill>
-          <a:ln>
-            <a:noFill/>
-          </a:ln>
-        </p:spPr>
-        <p:style>
-          <a:lnRef idx="1">
-            <a:schemeClr val="accent1"/>
-          </a:lnRef>
-          <a:fillRef idx="3">
-            <a:schemeClr val="accent1"/>
-          </a:fillRef>
-          <a:effectRef idx="2">
-            <a:schemeClr val="accent1"/>
-          </a:effectRef>
-          <a:fontRef idx="minor">
-            <a:schemeClr val="lt1"/>
-          </a:fontRef>
-        </p:style>
-        <p:txBody>
-          <a:bodyPr rtlCol="0" anchor="ctr"/>
-          <a:lstStyle/>
-          <a:p>
-            <a:pPr algn="ctr"/>
-          </a:p>
-        </p:txBody>
-      </p:sp>
-      <p:sp>
-        <p:nvSpPr>
-          <p:cNvPr id="8" name="Oval 7"/>
-          <p:cNvSpPr/>
-          <p:nvPr/>
-        </p:nvSpPr>
-        <p:spPr>
-          <a:xfrm>
-            <a:off x="210311" y="128016"/>
-            <a:ext cx="54864" cy="54864"/>
-          </a:xfrm>
-          <a:prstGeom prst="ellipse">
-            <a:avLst/>
-          </a:prstGeom>
-          <a:solidFill>
-            <a:srgbClr val="E5C07B"/>
-          </a:solidFill>
-          <a:ln>
-            <a:noFill/>
-          </a:ln>
-        </p:spPr>
-        <p:style>
-          <a:lnRef idx="1">
-            <a:schemeClr val="accent1"/>
-          </a:lnRef>
-          <a:fillRef idx="3">
-            <a:schemeClr val="accent1"/>
-          </a:fillRef>
-          <a:effectRef idx="2">
-            <a:schemeClr val="accent1"/>
-          </a:effectRef>
-          <a:fontRef idx="minor">
-            <a:schemeClr val="lt1"/>
-          </a:fontRef>
-        </p:style>
-        <p:txBody>
-          <a:bodyPr rtlCol="0" anchor="ctr"/>
-          <a:lstStyle/>
-          <a:p>
-            <a:pPr algn="ctr"/>
-          </a:p>
-        </p:txBody>
-      </p:sp>
-      <p:sp>
-        <p:nvSpPr>
-          <p:cNvPr id="9" name="Oval 8"/>
-          <p:cNvSpPr/>
-          <p:nvPr/>
-        </p:nvSpPr>
-        <p:spPr>
-          <a:xfrm>
-            <a:off x="283464" y="128016"/>
-            <a:ext cx="54864" cy="54864"/>
-          </a:xfrm>
-          <a:prstGeom prst="ellipse">
-            <a:avLst/>
-          </a:prstGeom>
-          <a:solidFill>
-            <a:srgbClr val="3FB950"/>
-          </a:solidFill>
-          <a:ln>
-            <a:noFill/>
-          </a:ln>
-        </p:spPr>
-        <p:style>
-          <a:lnRef idx="1">
-            <a:schemeClr val="accent1"/>
-          </a:lnRef>
-          <a:fillRef idx="3">
-            <a:schemeClr val="accent1"/>
-          </a:fillRef>
-          <a:effectRef idx="2">
-            <a:schemeClr val="accent1"/>
-          </a:effectRef>
-          <a:fontRef idx="minor">
-            <a:schemeClr val="lt1"/>
-          </a:fontRef>
-        </p:style>
-        <p:txBody>
-          <a:bodyPr rtlCol="0" anchor="ctr"/>
-          <a:lstStyle/>
-          <a:p>
-            <a:pPr algn="ctr"/>
-          </a:p>
-        </p:txBody>
-      </p:sp>
-      <p:sp>
-        <p:nvSpPr>
-          <p:cNvPr id="10" name="TextBox 9"/>
-          <p:cNvSpPr txBox="1"/>
-          <p:nvPr/>
-        </p:nvSpPr>
-        <p:spPr>
-          <a:xfrm>
-            <a:off x="457200" y="100584"/>
-            <a:ext cx="8229600" cy="182880"/>
+            <a:off x="457200" y="418063680000"/>
+            <a:ext cx="8229600" cy="228600"/>
           </a:xfrm>
           <a:prstGeom prst="rect">
             <a:avLst/>
@@ -3464,31 +3120,84 @@
             <a:spAutoFit/>
           </a:bodyPr>
           <a:lstStyle/>
-          <a:p>
-            <a:pPr algn="ctr">
-              <a:defRPr sz="800">
+          <a:p/>
+          <a:p>
+            <a:r>
+              <a:rPr sz="1100">
                 <a:solidFill>
                   <a:srgbClr val="8B949E"/>
                 </a:solidFill>
-                <a:latin typeface="Menlo"/>
-              </a:defRPr>
-            </a:pPr>
-            <a:r>
-              <a:t>presentation — mot@rs1-c724 — 100×40</a:t>
-            </a:r>
-          </a:p>
-        </p:txBody>
-      </p:sp>
-      <p:sp>
-        <p:nvSpPr>
-          <p:cNvPr id="11" name="TextBox 10"/>
+                <a:latin typeface="Meslo Nerd Font"/>
+              </a:rPr>
+              <a:t>╭─</a:t>
+            </a:r>
+            <a:r>
+              <a:rPr sz="1100" b="1">
+                <a:solidFill>
+                  <a:srgbClr val="56B6C2"/>
+                </a:solidFill>
+                <a:latin typeface="Meslo Nerd Font"/>
+              </a:rPr>
+              <a:t>  mot@rs1-c724 </a:t>
+            </a:r>
+            <a:r>
+              <a:rPr sz="1100">
+                <a:solidFill>
+                  <a:srgbClr val="8B949E"/>
+                </a:solidFill>
+                <a:latin typeface="Meslo Nerd Font"/>
+              </a:rPr>
+              <a:t> </a:t>
+            </a:r>
+            <a:r>
+              <a:rPr sz="1100">
+                <a:solidFill>
+                  <a:srgbClr val="D2A8FF"/>
+                </a:solidFill>
+                <a:latin typeface="Meslo Nerd Font"/>
+              </a:rPr>
+              <a:t> ~/presentation </a:t>
+            </a:r>
+            <a:r>
+              <a:rPr sz="1100">
+                <a:solidFill>
+                  <a:srgbClr val="8B949E"/>
+                </a:solidFill>
+                <a:latin typeface="Meslo Nerd Font"/>
+              </a:rPr>
+              <a:t> </a:t>
+            </a:r>
+            <a:r>
+              <a:rPr sz="1100">
+                <a:solidFill>
+                  <a:srgbClr val="3FB950"/>
+                </a:solidFill>
+                <a:latin typeface="Meslo Nerd Font"/>
+              </a:rPr>
+              <a:t> master </a:t>
+            </a:r>
+            <a:r>
+              <a:rPr sz="1100">
+                <a:solidFill>
+                  <a:srgbClr val="E5C07B"/>
+                </a:solidFill>
+                <a:latin typeface="Meslo Nerd Font"/>
+              </a:rPr>
+              <a:t>⚡</a:t>
+            </a:r>
+          </a:p>
+        </p:txBody>
+      </p:sp>
+      <p:sp>
+        <p:nvSpPr>
+          <p:cNvPr id="3" name="TextBox 2"/>
           <p:cNvSpPr txBox="1"/>
           <p:nvPr/>
         </p:nvSpPr>
         <p:spPr>
           <a:xfrm>
-            <a:off x="274320" y="376257312000"/>
-            <a:ext cx="8595360" cy="228600"/>
+            <a:off x="731520" y="1188720"/>
+            <a:ext cx="7680960" cy="1645920"/>
           </a:xfrm>
           <a:prstGeom prst="rect">
             <a:avLst/>
@@ -3500,84 +3209,54 @@
             <a:spAutoFit/>
           </a:bodyPr>
           <a:lstStyle/>
-          <a:p/>
-          <a:p>
-            <a:r>
-              <a:rPr sz="1100">
-                <a:solidFill>
-                  <a:srgbClr val="8B949E"/>
-                </a:solidFill>
-                <a:latin typeface="Menlo"/>
-              </a:rPr>
-              <a:t>╭─</a:t>
-            </a:r>
-            <a:r>
-              <a:rPr sz="1100" b="1">
-                <a:solidFill>
-                  <a:srgbClr val="56B6C2"/>
-                </a:solidFill>
-                <a:latin typeface="Menlo"/>
-              </a:rPr>
-              <a:t>  mot@rs1-c724 </a:t>
-            </a:r>
-            <a:r>
-              <a:rPr sz="1100">
-                <a:solidFill>
-                  <a:srgbClr val="8B949E"/>
-                </a:solidFill>
-                <a:latin typeface="Menlo"/>
-              </a:rPr>
-              <a:t> </a:t>
-            </a:r>
-            <a:r>
-              <a:rPr sz="1100">
-                <a:solidFill>
-                  <a:srgbClr val="D2A8FF"/>
-                </a:solidFill>
-                <a:latin typeface="Menlo"/>
-              </a:rPr>
-              <a:t> ~/presentation </a:t>
-            </a:r>
-            <a:r>
-              <a:rPr sz="1100">
-                <a:solidFill>
-                  <a:srgbClr val="8B949E"/>
-                </a:solidFill>
-                <a:latin typeface="Menlo"/>
-              </a:rPr>
-              <a:t> </a:t>
-            </a:r>
-            <a:r>
-              <a:rPr sz="1100">
-                <a:solidFill>
-                  <a:srgbClr val="3FB950"/>
-                </a:solidFill>
-                <a:latin typeface="Menlo"/>
-              </a:rPr>
-              <a:t> master </a:t>
-            </a:r>
-            <a:r>
-              <a:rPr sz="1100">
-                <a:solidFill>
-                  <a:srgbClr val="E5C07B"/>
-                </a:solidFill>
-                <a:latin typeface="Menlo"/>
-              </a:rPr>
-              <a:t>⚡</a:t>
-            </a:r>
-          </a:p>
-        </p:txBody>
-      </p:sp>
-      <p:sp>
-        <p:nvSpPr>
-          <p:cNvPr id="12" name="TextBox 11"/>
+          <a:p>
+            <a:pPr>
+              <a:lnSpc>
+                <a:spcPct val="90000"/>
+              </a:lnSpc>
+              <a:defRPr sz="1000">
+                <a:solidFill>
+                  <a:srgbClr val="58A6FF"/>
+                </a:solidFill>
+                <a:latin typeface="Meslo Nerd Font"/>
+              </a:defRPr>
+            </a:pPr>
+            <a:r>
+              <a:t>███╗   ███╗  █████╗  ██████╗  ███████╗ </a:t>
+            </a:r>
+          </a:p>
+          <a:p>
+            <a:r>
+              <a:t>████╗ ████║ ██╔══██╗ ██╔════╝ ██╔════╝ </a:t>
+            </a:r>
+          </a:p>
+          <a:p>
+            <a:r>
+              <a:t>██╔████╔██║ ███████║ ██║      █████╗   </a:t>
+            </a:r>
+          </a:p>
+          <a:p>
+            <a:r>
+              <a:t>██║╚██╔╝██║ ██╔══██║ ██║      ██╔══╝   </a:t>
+            </a:r>
+          </a:p>
+          <a:p>
+            <a:r>
+              <a:t>██║ ╚═╝ ██║ ██║  ██║ ╚██████╗ ███████╗ </a:t>
+            </a:r>
+          </a:p>
+        </p:txBody>
+      </p:sp>
+      <p:sp>
+        <p:nvSpPr>
+          <p:cNvPr id="4" name="TextBox 3"/>
           <p:cNvSpPr txBox="1"/>
           <p:nvPr/>
         </p:nvSpPr>
         <p:spPr>
           <a:xfrm>
-            <a:off x="274320" y="376257540600"/>
-            <a:ext cx="8595360" cy="228600"/>
+            <a:off x="1371600" y="2926080"/>
+            <a:ext cx="6400800" cy="457200"/>
           </a:xfrm>
           <a:prstGeom prst="rect">
             <a:avLst/>
@@ -3589,48 +3268,31 @@
             <a:spAutoFit/>
           </a:bodyPr>
           <a:lstStyle/>
-          <a:p/>
-          <a:p>
-            <a:r>
-              <a:rPr sz="1100">
-                <a:solidFill>
-                  <a:srgbClr val="8B949E"/>
-                </a:solidFill>
-                <a:latin typeface="Menlo"/>
-              </a:rPr>
-              <a:t>╰─</a:t>
-            </a:r>
-            <a:r>
-              <a:rPr sz="1200" b="1">
-                <a:solidFill>
-                  <a:srgbClr val="3FB950"/>
-                </a:solidFill>
-                <a:latin typeface="Menlo"/>
-              </a:rPr>
-              <a:t>❯ </a:t>
-            </a:r>
-            <a:r>
-              <a:rPr sz="1100">
-                <a:solidFill>
-                  <a:srgbClr val="C9D1D9"/>
-                </a:solidFill>
-                <a:latin typeface="Menlo"/>
-              </a:rPr>
-              <a:t>./run_presentation.sh</a:t>
-            </a:r>
-          </a:p>
-        </p:txBody>
-      </p:sp>
-      <p:sp>
-        <p:nvSpPr>
-          <p:cNvPr id="13" name="TextBox 12"/>
+          <a:p>
+            <a:pPr algn="ctr">
+              <a:defRPr sz="2000" b="1">
+                <a:solidFill>
+                  <a:srgbClr val="D2A8FF"/>
+                </a:solidFill>
+                <a:latin typeface="Meslo Nerd Font"/>
+              </a:defRPr>
+            </a:pPr>
+            <a:r>
+              <a:t>&gt;&gt;&gt; Gaussian Interface &lt;&lt;&lt;</a:t>
+            </a:r>
+          </a:p>
+        </p:txBody>
+      </p:sp>
+      <p:sp>
+        <p:nvSpPr>
+          <p:cNvPr id="5" name="TextBox 4"/>
           <p:cNvSpPr txBox="1"/>
           <p:nvPr/>
         </p:nvSpPr>
         <p:spPr>
           <a:xfrm>
-            <a:off x="548640" y="1005840"/>
-            <a:ext cx="8046720" cy="1645920"/>
+            <a:off x="1645920" y="3657600"/>
+            <a:ext cx="5852160" cy="1097280"/>
           </a:xfrm>
           <a:prstGeom prst="rect">
             <a:avLst/>
@@ -3645,51 +3307,63 @@
           <a:p>
             <a:pPr>
               <a:lnSpc>
-                <a:spcPct val="90000"/>
+                <a:spcPct val="140000"/>
               </a:lnSpc>
-              <a:defRPr sz="1000">
-                <a:solidFill>
-                  <a:srgbClr val="58A6FF"/>
-                </a:solidFill>
-                <a:latin typeface="Menlo"/>
+              <a:defRPr sz="1300">
+                <a:solidFill>
+                  <a:srgbClr val="E5C07B"/>
+                </a:solidFill>
+                <a:latin typeface="Meslo Nerd Font"/>
               </a:defRPr>
             </a:pPr>
             <a:r>
-              <a:t>███╗   ███╗  █████╗  ██████╗  ███████╗ </a:t>
-            </a:r>
-          </a:p>
-          <a:p>
-            <a:r>
-              <a:t>████╗ ████║ ██╔══██╗ ██╔════╝ ██╔════╝ </a:t>
-            </a:r>
-          </a:p>
-          <a:p>
-            <a:r>
-              <a:t>██╔████╔██║ ███████║ ██║      █████╗   </a:t>
-            </a:r>
-          </a:p>
-          <a:p>
-            <a:r>
-              <a:t>██║╚██╔╝██║ ██╔══██║ ██║      ██╔══╝   </a:t>
-            </a:r>
-          </a:p>
-          <a:p>
-            <a:r>
-              <a:t>██║ ╚═╝ ██║ ██║  ██║ ╚██████╗ ███████╗ </a:t>
-            </a:r>
-          </a:p>
-        </p:txBody>
-      </p:sp>
-      <p:sp>
-        <p:nvSpPr>
-          <p:cNvPr id="14" name="TextBox 13"/>
+              <a:t>⚡ ML-Accelerated Anharmonic IR Spectroscopy</a:t>
+            </a:r>
+          </a:p>
+          <a:p>
+            <a:pPr>
+              <a:lnSpc>
+                <a:spcPct val="140000"/>
+              </a:lnSpc>
+              <a:defRPr sz="1300">
+                <a:solidFill>
+                  <a:srgbClr val="56B6C2"/>
+                </a:solidFill>
+                <a:latin typeface="Meslo Nerd Font"/>
+              </a:defRPr>
+            </a:pPr>
+            <a:r>
+              <a:t>🔬 Hybrid ML-QM Approach</a:t>
+            </a:r>
+          </a:p>
+          <a:p>
+            <a:pPr>
+              <a:lnSpc>
+                <a:spcPct val="140000"/>
+              </a:lnSpc>
+              <a:defRPr sz="1300">
+                <a:solidFill>
+                  <a:srgbClr val="3FB950"/>
+                </a:solidFill>
+                <a:latin typeface="Meslo Nerd Font"/>
+              </a:defRPr>
+            </a:pPr>
+            <a:r>
+              <a:t>🚀 10-100× Speedup</a:t>
+            </a:r>
+          </a:p>
+        </p:txBody>
+      </p:sp>
+      <p:sp>
+        <p:nvSpPr>
+          <p:cNvPr id="6" name="TextBox 5"/>
           <p:cNvSpPr txBox="1"/>
           <p:nvPr/>
         </p:nvSpPr>
         <p:spPr>
           <a:xfrm>
-            <a:off x="914400" y="2743200"/>
-            <a:ext cx="7315200" cy="457200"/>
+            <a:off x="1371600" y="5486400"/>
+            <a:ext cx="6400800" cy="457200"/>
           </a:xfrm>
           <a:prstGeom prst="rect">
             <a:avLst/>
@@ -3703,214 +3377,28 @@
           <a:lstStyle/>
           <a:p>
             <a:pPr algn="ctr">
-              <a:defRPr sz="2000" b="1">
-                <a:solidFill>
-                  <a:srgbClr val="D2A8FF"/>
-                </a:solidFill>
-                <a:latin typeface="Menlo"/>
+              <a:defRPr sz="1100">
+                <a:solidFill>
+                  <a:srgbClr val="8B949E"/>
+                </a:solidFill>
+                <a:latin typeface="Meslo Nerd Font"/>
               </a:defRPr>
             </a:pPr>
             <a:r>
-              <a:t>&gt;&gt;&gt; Gaussian Interface &lt;&lt;&lt;</a:t>
-            </a:r>
-          </a:p>
-        </p:txBody>
-      </p:sp>
-      <p:sp>
-        <p:nvSpPr>
-          <p:cNvPr id="15" name="TextBox 14"/>
+              <a:t>Your Name  │  Research Group  │  2025-11-15</a:t>
+            </a:r>
+          </a:p>
+        </p:txBody>
+      </p:sp>
+      <p:sp>
+        <p:nvSpPr>
+          <p:cNvPr id="7" name="TextBox 6"/>
           <p:cNvSpPr txBox="1"/>
           <p:nvPr/>
         </p:nvSpPr>
         <p:spPr>
           <a:xfrm>
-            <a:off x="1371600" y="3383280"/>
-            <a:ext cx="6400800" cy="1097280"/>
-          </a:xfrm>
-          <a:prstGeom prst="rect">
-            <a:avLst/>
-          </a:prstGeom>
-          <a:noFill/>
-        </p:spPr>
-        <p:txBody>
-          <a:bodyPr wrap="none">
-            <a:spAutoFit/>
-          </a:bodyPr>
-          <a:lstStyle/>
-          <a:p>
-            <a:pPr>
-              <a:lnSpc>
-                <a:spcPct val="140000"/>
-              </a:lnSpc>
-              <a:defRPr sz="1300">
-                <a:solidFill>
-                  <a:srgbClr val="E5C07B"/>
-                </a:solidFill>
-                <a:latin typeface="Menlo"/>
-              </a:defRPr>
-            </a:pPr>
-            <a:r>
-              <a:t>⚡ ML-Accelerated Anharmonic IR Spectroscopy</a:t>
-            </a:r>
-          </a:p>
-          <a:p>
-            <a:pPr>
-              <a:lnSpc>
-                <a:spcPct val="140000"/>
-              </a:lnSpc>
-              <a:defRPr sz="1300">
-                <a:solidFill>
-                  <a:srgbClr val="56B6C2"/>
-                </a:solidFill>
-                <a:latin typeface="Menlo"/>
-              </a:defRPr>
-            </a:pPr>
-            <a:r>
-              <a:t>🔬 Hybrid ML-QM Approach</a:t>
-            </a:r>
-          </a:p>
-          <a:p>
-            <a:pPr>
-              <a:lnSpc>
-                <a:spcPct val="140000"/>
-              </a:lnSpc>
-              <a:defRPr sz="1300">
-                <a:solidFill>
-                  <a:srgbClr val="3FB950"/>
-                </a:solidFill>
-                <a:latin typeface="Menlo"/>
-              </a:defRPr>
-            </a:pPr>
-            <a:r>
-              <a:t>🚀 10-100× Speedup</a:t>
-            </a:r>
-          </a:p>
-        </p:txBody>
-      </p:sp>
-      <p:sp>
-        <p:nvSpPr>
-          <p:cNvPr id="16" name="TextBox 15"/>
-          <p:cNvSpPr txBox="1"/>
-          <p:nvPr/>
-        </p:nvSpPr>
-        <p:spPr>
-          <a:xfrm>
-            <a:off x="914400" y="5029200"/>
-            <a:ext cx="7315200" cy="457200"/>
-          </a:xfrm>
-          <a:prstGeom prst="rect">
-            <a:avLst/>
-          </a:prstGeom>
-          <a:noFill/>
-        </p:spPr>
-        <p:txBody>
-          <a:bodyPr wrap="none">
-            <a:spAutoFit/>
-          </a:bodyPr>
-          <a:lstStyle/>
-          <a:p>
-            <a:pPr algn="ctr">
-              <a:defRPr sz="1100">
-                <a:solidFill>
-                  <a:srgbClr val="8B949E"/>
-                </a:solidFill>
-                <a:latin typeface="Menlo"/>
-              </a:defRPr>
-            </a:pPr>
-            <a:r>
-              <a:t>Your Name  │  Research Group  │  2025-11-15</a:t>
-            </a:r>
-          </a:p>
-        </p:txBody>
-      </p:sp>
-      <p:sp>
-        <p:nvSpPr>
-          <p:cNvPr id="17" name="Rectangle 16"/>
-          <p:cNvSpPr/>
-          <p:nvPr/>
-        </p:nvSpPr>
-        <p:spPr>
-          <a:xfrm>
-            <a:off x="45720" y="6537960"/>
-            <a:ext cx="9052560" cy="228600"/>
-          </a:xfrm>
-          <a:prstGeom prst="rect">
-            <a:avLst/>
-          </a:prstGeom>
-          <a:solidFill>
-            <a:srgbClr val="161B22"/>
-          </a:solidFill>
-          <a:ln>
-            <a:noFill/>
-          </a:ln>
-        </p:spPr>
-        <p:style>
-          <a:lnRef idx="1">
-            <a:schemeClr val="accent1"/>
-          </a:lnRef>
-          <a:fillRef idx="3">
-            <a:schemeClr val="accent1"/>
-          </a:fillRef>
-          <a:effectRef idx="2">
-            <a:schemeClr val="accent1"/>
-          </a:effectRef>
-          <a:fontRef idx="minor">
-            <a:schemeClr val="lt1"/>
-          </a:fontRef>
-        </p:style>
-        <p:txBody>
-          <a:bodyPr rtlCol="0" anchor="ctr"/>
-          <a:lstStyle/>
-          <a:p>
-            <a:pPr algn="ctr"/>
-          </a:p>
-        </p:txBody>
-      </p:sp>
-      <p:sp>
-        <p:nvSpPr>
-          <p:cNvPr id="18" name="TextBox 17"/>
-          <p:cNvSpPr txBox="1"/>
-          <p:nvPr/>
-        </p:nvSpPr>
-        <p:spPr>
-          <a:xfrm>
-            <a:off x="274320" y="6565392"/>
-            <a:ext cx="8595360" cy="182880"/>
-          </a:xfrm>
-          <a:prstGeom prst="rect">
-            <a:avLst/>
-          </a:prstGeom>
-          <a:noFill/>
-        </p:spPr>
-        <p:txBody>
-          <a:bodyPr wrap="none">
-            <a:spAutoFit/>
-          </a:bodyPr>
-          <a:lstStyle/>
-          <a:p>
-            <a:pPr>
-              <a:defRPr sz="900">
-                <a:solidFill>
-                  <a:srgbClr val="C9D1D9"/>
-                </a:solidFill>
-                <a:latin typeface="Menlo"/>
-              </a:defRPr>
-            </a:pPr>
-            <a:r>
-              <a:t>[1/10] ⚡ NORMAL  presentation.sh</a:t>
-            </a:r>
-          </a:p>
-        </p:txBody>
-      </p:sp>
-      <p:sp>
-        <p:nvSpPr>
-          <p:cNvPr id="19" name="TextBox 18"/>
-          <p:cNvSpPr txBox="1"/>
-          <p:nvPr/>
-        </p:nvSpPr>
-        <p:spPr>
-          <a:xfrm>
-            <a:off x="4480560" y="5760720"/>
+            <a:off x="4480560" y="6217920"/>
             <a:ext cx="182880" cy="274320"/>
           </a:xfrm>
           <a:prstGeom prst="rect">
@@ -3929,7 +3417,7 @@
                 <a:solidFill>
                   <a:srgbClr val="3FB950"/>
                 </a:solidFill>
-                <a:latin typeface="Menlo"/>
+                <a:latin typeface="Meslo Nerd Font"/>
               </a:defRPr>
             </a:pPr>
             <a:r>
@@ -3966,173 +3454,378 @@
       <p:grpSpPr/>
       <p:sp>
         <p:nvSpPr>
-          <p:cNvPr id="2" name="Rectangle 1"/>
-          <p:cNvSpPr/>
+          <p:cNvPr id="2" name="TextBox 1"/>
+          <p:cNvSpPr txBox="1"/>
           <p:nvPr/>
         </p:nvSpPr>
         <p:spPr>
           <a:xfrm>
-            <a:off x="0" y="0"/>
-            <a:ext cx="9144000" cy="45720"/>
+            <a:off x="457200" y="418063680000"/>
+            <a:ext cx="8229600" cy="228600"/>
           </a:xfrm>
           <a:prstGeom prst="rect">
             <a:avLst/>
           </a:prstGeom>
-          <a:solidFill>
-            <a:srgbClr val="30363D"/>
-          </a:solidFill>
-          <a:ln>
-            <a:noFill/>
-          </a:ln>
+          <a:noFill/>
         </p:spPr>
-        <p:style>
-          <a:lnRef idx="1">
-            <a:schemeClr val="accent1"/>
-          </a:lnRef>
-          <a:fillRef idx="3">
-            <a:schemeClr val="accent1"/>
-          </a:fillRef>
-          <a:effectRef idx="2">
-            <a:schemeClr val="accent1"/>
-          </a:effectRef>
-          <a:fontRef idx="minor">
-            <a:schemeClr val="lt1"/>
-          </a:fontRef>
-        </p:style>
-        <p:txBody>
-          <a:bodyPr rtlCol="0" anchor="ctr"/>
-          <a:lstStyle/>
-          <a:p>
-            <a:pPr algn="ctr"/>
-          </a:p>
-        </p:txBody>
-      </p:sp>
-      <p:sp>
-        <p:nvSpPr>
-          <p:cNvPr id="3" name="Rectangle 2"/>
-          <p:cNvSpPr/>
+        <p:txBody>
+          <a:bodyPr wrap="none">
+            <a:spAutoFit/>
+          </a:bodyPr>
+          <a:lstStyle/>
+          <a:p/>
+          <a:p>
+            <a:r>
+              <a:rPr sz="1100">
+                <a:solidFill>
+                  <a:srgbClr val="8B949E"/>
+                </a:solidFill>
+                <a:latin typeface="Meslo Nerd Font"/>
+              </a:rPr>
+              <a:t>╭─</a:t>
+            </a:r>
+            <a:r>
+              <a:rPr sz="1100" b="1">
+                <a:solidFill>
+                  <a:srgbClr val="56B6C2"/>
+                </a:solidFill>
+                <a:latin typeface="Meslo Nerd Font"/>
+              </a:rPr>
+              <a:t>  mot@rs1-c724 </a:t>
+            </a:r>
+            <a:r>
+              <a:rPr sz="1100">
+                <a:solidFill>
+                  <a:srgbClr val="8B949E"/>
+                </a:solidFill>
+                <a:latin typeface="Meslo Nerd Font"/>
+              </a:rPr>
+              <a:t> </a:t>
+            </a:r>
+            <a:r>
+              <a:rPr sz="1100">
+                <a:solidFill>
+                  <a:srgbClr val="D2A8FF"/>
+                </a:solidFill>
+                <a:latin typeface="Meslo Nerd Font"/>
+              </a:rPr>
+              <a:t> ~/presentation </a:t>
+            </a:r>
+            <a:r>
+              <a:rPr sz="1100">
+                <a:solidFill>
+                  <a:srgbClr val="8B949E"/>
+                </a:solidFill>
+                <a:latin typeface="Meslo Nerd Font"/>
+              </a:rPr>
+              <a:t> </a:t>
+            </a:r>
+            <a:r>
+              <a:rPr sz="1100">
+                <a:solidFill>
+                  <a:srgbClr val="3FB950"/>
+                </a:solidFill>
+                <a:latin typeface="Meslo Nerd Font"/>
+              </a:rPr>
+              <a:t> master </a:t>
+            </a:r>
+            <a:r>
+              <a:rPr sz="1100">
+                <a:solidFill>
+                  <a:srgbClr val="E5C07B"/>
+                </a:solidFill>
+                <a:latin typeface="Meslo Nerd Font"/>
+              </a:rPr>
+              <a:t>⚡</a:t>
+            </a:r>
+          </a:p>
+        </p:txBody>
+      </p:sp>
+      <p:sp>
+        <p:nvSpPr>
+          <p:cNvPr id="3" name="TextBox 2"/>
+          <p:cNvSpPr txBox="1"/>
           <p:nvPr/>
         </p:nvSpPr>
         <p:spPr>
           <a:xfrm>
-            <a:off x="0" y="6812280"/>
-            <a:ext cx="9144000" cy="45720"/>
+            <a:off x="457200" y="418063908600"/>
+            <a:ext cx="8229600" cy="228600"/>
           </a:xfrm>
           <a:prstGeom prst="rect">
             <a:avLst/>
           </a:prstGeom>
-          <a:solidFill>
-            <a:srgbClr val="30363D"/>
-          </a:solidFill>
-          <a:ln>
-            <a:noFill/>
-          </a:ln>
+          <a:noFill/>
         </p:spPr>
-        <p:style>
-          <a:lnRef idx="1">
-            <a:schemeClr val="accent1"/>
-          </a:lnRef>
-          <a:fillRef idx="3">
-            <a:schemeClr val="accent1"/>
-          </a:fillRef>
-          <a:effectRef idx="2">
-            <a:schemeClr val="accent1"/>
-          </a:effectRef>
-          <a:fontRef idx="minor">
-            <a:schemeClr val="lt1"/>
-          </a:fontRef>
-        </p:style>
-        <p:txBody>
-          <a:bodyPr rtlCol="0" anchor="ctr"/>
-          <a:lstStyle/>
-          <a:p>
-            <a:pPr algn="ctr"/>
-          </a:p>
-        </p:txBody>
-      </p:sp>
-      <p:sp>
-        <p:nvSpPr>
-          <p:cNvPr id="4" name="Rectangle 3"/>
-          <p:cNvSpPr/>
+        <p:txBody>
+          <a:bodyPr wrap="none">
+            <a:spAutoFit/>
+          </a:bodyPr>
+          <a:lstStyle/>
+          <a:p/>
+          <a:p>
+            <a:r>
+              <a:rPr sz="1100">
+                <a:solidFill>
+                  <a:srgbClr val="8B949E"/>
+                </a:solidFill>
+                <a:latin typeface="Meslo Nerd Font"/>
+              </a:rPr>
+              <a:t>╰─</a:t>
+            </a:r>
+            <a:r>
+              <a:rPr sz="1200" b="1">
+                <a:solidFill>
+                  <a:srgbClr val="3FB950"/>
+                </a:solidFill>
+                <a:latin typeface="Meslo Nerd Font"/>
+              </a:rPr>
+              <a:t>❯ </a:t>
+            </a:r>
+            <a:r>
+              <a:rPr sz="1100">
+                <a:solidFill>
+                  <a:srgbClr val="C9D1D9"/>
+                </a:solidFill>
+                <a:latin typeface="Meslo Nerd Font"/>
+              </a:rPr>
+              <a:t>cat motivation.md</a:t>
+            </a:r>
+          </a:p>
+        </p:txBody>
+      </p:sp>
+      <p:sp>
+        <p:nvSpPr>
+          <p:cNvPr id="4" name="TextBox 3"/>
+          <p:cNvSpPr txBox="1"/>
           <p:nvPr/>
         </p:nvSpPr>
         <p:spPr>
           <a:xfrm>
-            <a:off x="0" y="0"/>
-            <a:ext cx="45720" cy="6858000"/>
+            <a:off x="731520" y="1097280"/>
+            <a:ext cx="7680960" cy="548640"/>
           </a:xfrm>
           <a:prstGeom prst="rect">
             <a:avLst/>
           </a:prstGeom>
-          <a:solidFill>
-            <a:srgbClr val="30363D"/>
-          </a:solidFill>
-          <a:ln>
-            <a:noFill/>
-          </a:ln>
+          <a:noFill/>
         </p:spPr>
-        <p:style>
-          <a:lnRef idx="1">
-            <a:schemeClr val="accent1"/>
-          </a:lnRef>
-          <a:fillRef idx="3">
-            <a:schemeClr val="accent1"/>
-          </a:fillRef>
-          <a:effectRef idx="2">
-            <a:schemeClr val="accent1"/>
-          </a:effectRef>
-          <a:fontRef idx="minor">
-            <a:schemeClr val="lt1"/>
-          </a:fontRef>
-        </p:style>
-        <p:txBody>
-          <a:bodyPr rtlCol="0" anchor="ctr"/>
-          <a:lstStyle/>
-          <a:p>
-            <a:pPr algn="ctr"/>
-          </a:p>
-        </p:txBody>
-      </p:sp>
-      <p:sp>
-        <p:nvSpPr>
-          <p:cNvPr id="5" name="Rectangle 4"/>
-          <p:cNvSpPr/>
+        <p:txBody>
+          <a:bodyPr wrap="none">
+            <a:spAutoFit/>
+          </a:bodyPr>
+          <a:lstStyle/>
+          <a:p>
+            <a:pPr>
+              <a:lnSpc>
+                <a:spcPct val="90000"/>
+              </a:lnSpc>
+              <a:defRPr sz="1000">
+                <a:solidFill>
+                  <a:srgbClr val="58A6FF"/>
+                </a:solidFill>
+                <a:latin typeface="Meslo Nerd Font"/>
+              </a:defRPr>
+            </a:pPr>
+            <a:r>
+              <a:t>╔══════════════════════════════════════╗</a:t>
+            </a:r>
+          </a:p>
+          <a:p>
+            <a:r>
+              <a:t>║               MOTIVATION               ║</a:t>
+            </a:r>
+          </a:p>
+          <a:p>
+            <a:r>
+              <a:t>╚══════════════════════════════════════╝</a:t>
+            </a:r>
+          </a:p>
+        </p:txBody>
+      </p:sp>
+      <p:sp>
+        <p:nvSpPr>
+          <p:cNvPr id="5" name="TextBox 4"/>
+          <p:cNvSpPr txBox="1"/>
           <p:nvPr/>
         </p:nvSpPr>
         <p:spPr>
           <a:xfrm>
-            <a:off x="9098280" y="0"/>
-            <a:ext cx="45720" cy="6858000"/>
+            <a:off x="731520" y="1828800"/>
+            <a:ext cx="7680960" cy="4572000"/>
           </a:xfrm>
           <a:prstGeom prst="rect">
             <a:avLst/>
           </a:prstGeom>
-          <a:solidFill>
-            <a:srgbClr val="30363D"/>
-          </a:solidFill>
-          <a:ln>
-            <a:noFill/>
-          </a:ln>
+          <a:noFill/>
         </p:spPr>
-        <p:style>
-          <a:lnRef idx="1">
-            <a:schemeClr val="accent1"/>
-          </a:lnRef>
-          <a:fillRef idx="3">
-            <a:schemeClr val="accent1"/>
-          </a:fillRef>
-          <a:effectRef idx="2">
-            <a:schemeClr val="accent1"/>
-          </a:effectRef>
-          <a:fontRef idx="minor">
-            <a:schemeClr val="lt1"/>
-          </a:fontRef>
-        </p:style>
-        <p:txBody>
-          <a:bodyPr rtlCol="0" anchor="ctr"/>
-          <a:lstStyle/>
-          <a:p>
-            <a:pPr algn="ctr"/>
+        <p:txBody>
+          <a:bodyPr wrap="none">
+            <a:spAutoFit/>
+          </a:bodyPr>
+          <a:lstStyle/>
+          <a:p>
+            <a:pPr>
+              <a:defRPr sz="1200">
+                <a:solidFill>
+                  <a:srgbClr val="D2A8FF"/>
+                </a:solidFill>
+                <a:latin typeface="Meslo Nerd Font"/>
+              </a:defRPr>
+            </a:pPr>
+            <a:r>
+              <a:t># Problem Statement</a:t>
+            </a:r>
+          </a:p>
+          <a:p>
+            <a:pPr>
+              <a:defRPr sz="1200">
+                <a:solidFill>
+                  <a:srgbClr val="C9D1D9"/>
+                </a:solidFill>
+                <a:latin typeface="Meslo Nerd Font"/>
+              </a:defRPr>
+            </a:pPr>
+            <a:r>
+              <a:t>  → DFT anharmonic calculations: expensive</a:t>
+            </a:r>
+          </a:p>
+          <a:p>
+            <a:pPr>
+              <a:defRPr sz="1200">
+                <a:solidFill>
+                  <a:srgbClr val="C9D1D9"/>
+                </a:solidFill>
+                <a:latin typeface="Meslo Nerd Font"/>
+              </a:defRPr>
+            </a:pPr>
+            <a:r>
+              <a:t>  → Hours to days per molecule</a:t>
+            </a:r>
+          </a:p>
+          <a:p>
+            <a:pPr>
+              <a:defRPr sz="1200">
+                <a:solidFill>
+                  <a:srgbClr val="C9D1D9"/>
+                </a:solidFill>
+                <a:latin typeface="Meslo Nerd Font"/>
+              </a:defRPr>
+            </a:pPr>
+            <a:r>
+              <a:t>  → Limits high-throughput applications</a:t>
+            </a:r>
+          </a:p>
+          <a:p>
+            <a:pPr>
+              <a:defRPr sz="1200">
+                <a:solidFill>
+                  <a:srgbClr val="C9D1D9"/>
+                </a:solidFill>
+                <a:latin typeface="Meslo Nerd Font"/>
+              </a:defRPr>
+            </a:pPr>
+          </a:p>
+          <a:p>
+            <a:pPr>
+              <a:defRPr sz="1200">
+                <a:solidFill>
+                  <a:srgbClr val="D2A8FF"/>
+                </a:solidFill>
+                <a:latin typeface="Meslo Nerd Font"/>
+              </a:defRPr>
+            </a:pPr>
+            <a:r>
+              <a:t># Our Solution</a:t>
+            </a:r>
+          </a:p>
+          <a:p>
+            <a:pPr>
+              <a:defRPr sz="1200">
+                <a:solidFill>
+                  <a:srgbClr val="3FB950"/>
+                </a:solidFill>
+                <a:latin typeface="Meslo Nerd Font"/>
+              </a:defRPr>
+            </a:pPr>
+            <a:r>
+              <a:t>  → ML potentials for fast components</a:t>
+            </a:r>
+          </a:p>
+          <a:p>
+            <a:pPr>
+              <a:defRPr sz="1200">
+                <a:solidFill>
+                  <a:srgbClr val="3FB950"/>
+                </a:solidFill>
+                <a:latin typeface="Meslo Nerd Font"/>
+              </a:defRPr>
+            </a:pPr>
+            <a:r>
+              <a:t>  → Gaussian for anharmonic corrections</a:t>
+            </a:r>
+          </a:p>
+          <a:p>
+            <a:pPr>
+              <a:defRPr sz="1200">
+                <a:solidFill>
+                  <a:srgbClr val="56B6C2"/>
+                </a:solidFill>
+                <a:latin typeface="Meslo Nerd Font"/>
+              </a:defRPr>
+            </a:pPr>
+            <a:r>
+              <a:t>  → ZMQ bridge for real-time communication</a:t>
+            </a:r>
+          </a:p>
+          <a:p>
+            <a:pPr>
+              <a:defRPr sz="1200">
+                <a:solidFill>
+                  <a:srgbClr val="C9D1D9"/>
+                </a:solidFill>
+                <a:latin typeface="Meslo Nerd Font"/>
+              </a:defRPr>
+            </a:pPr>
+          </a:p>
+          <a:p>
+            <a:pPr>
+              <a:defRPr sz="1200">
+                <a:solidFill>
+                  <a:srgbClr val="D2A8FF"/>
+                </a:solidFill>
+                <a:latin typeface="Meslo Nerd Font"/>
+              </a:defRPr>
+            </a:pPr>
+            <a:r>
+              <a:t># Impact</a:t>
+            </a:r>
+          </a:p>
+          <a:p>
+            <a:pPr>
+              <a:defRPr sz="1200">
+                <a:solidFill>
+                  <a:srgbClr val="E5C07B"/>
+                </a:solidFill>
+                <a:latin typeface="Meslo Nerd Font"/>
+              </a:defRPr>
+            </a:pPr>
+            <a:r>
+              <a:t>  ⚡ 10-100× computational speedup</a:t>
+            </a:r>
+          </a:p>
+          <a:p>
+            <a:pPr>
+              <a:defRPr sz="1200">
+                <a:solidFill>
+                  <a:srgbClr val="3FB950"/>
+                </a:solidFill>
+                <a:latin typeface="Meslo Nerd Font"/>
+              </a:defRPr>
+            </a:pPr>
+            <a:r>
+              <a:t>  ✓ Comparable accuracy to pure DFT</a:t>
+            </a:r>
           </a:p>
         </p:txBody>
       </p:sp>
@@ -4144,8 +3837,8 @@
         </p:nvSpPr>
         <p:spPr>
           <a:xfrm>
-            <a:off x="45720" y="73152"/>
-            <a:ext cx="9052560" cy="228600"/>
+            <a:off x="0" y="6629400"/>
+            <a:ext cx="9144000" cy="228600"/>
           </a:xfrm>
           <a:prstGeom prst="rect">
             <a:avLst/>
@@ -4187,7 +3880,7 @@
         </p:nvSpPr>
         <p:spPr>
           <a:xfrm>
-            <a:off x="457200" y="100584"/>
+            <a:off x="457200" y="6656832"/>
             <a:ext cx="8229600" cy="182880"/>
           </a:xfrm>
           <a:prstGeom prst="rect">
@@ -4201,468 +3894,12 @@
           </a:bodyPr>
           <a:lstStyle/>
           <a:p>
-            <a:pPr algn="ctr">
-              <a:defRPr sz="800">
-                <a:solidFill>
-                  <a:srgbClr val="8B949E"/>
-                </a:solidFill>
-                <a:latin typeface="Menlo"/>
-              </a:defRPr>
-            </a:pPr>
-            <a:r>
-              <a:t>presentation — mot@rs1-c724</a:t>
-            </a:r>
-          </a:p>
-        </p:txBody>
-      </p:sp>
-      <p:sp>
-        <p:nvSpPr>
-          <p:cNvPr id="8" name="TextBox 7"/>
-          <p:cNvSpPr txBox="1"/>
-          <p:nvPr/>
-        </p:nvSpPr>
-        <p:spPr>
-          <a:xfrm>
-            <a:off x="274320" y="376257312000"/>
-            <a:ext cx="8595360" cy="228600"/>
-          </a:xfrm>
-          <a:prstGeom prst="rect">
-            <a:avLst/>
-          </a:prstGeom>
-          <a:noFill/>
-        </p:spPr>
-        <p:txBody>
-          <a:bodyPr wrap="none">
-            <a:spAutoFit/>
-          </a:bodyPr>
-          <a:lstStyle/>
-          <a:p/>
-          <a:p>
-            <a:r>
-              <a:rPr sz="1100">
-                <a:solidFill>
-                  <a:srgbClr val="8B949E"/>
-                </a:solidFill>
-                <a:latin typeface="Menlo"/>
-              </a:rPr>
-              <a:t>╭─</a:t>
-            </a:r>
-            <a:r>
-              <a:rPr sz="1100" b="1">
-                <a:solidFill>
-                  <a:srgbClr val="56B6C2"/>
-                </a:solidFill>
-                <a:latin typeface="Menlo"/>
-              </a:rPr>
-              <a:t>  mot@rs1-c724 </a:t>
-            </a:r>
-            <a:r>
-              <a:rPr sz="1100">
-                <a:solidFill>
-                  <a:srgbClr val="8B949E"/>
-                </a:solidFill>
-                <a:latin typeface="Menlo"/>
-              </a:rPr>
-              <a:t> </a:t>
-            </a:r>
-            <a:r>
-              <a:rPr sz="1100">
-                <a:solidFill>
-                  <a:srgbClr val="D2A8FF"/>
-                </a:solidFill>
-                <a:latin typeface="Menlo"/>
-              </a:rPr>
-              <a:t> ~/presentation </a:t>
-            </a:r>
-            <a:r>
-              <a:rPr sz="1100">
-                <a:solidFill>
-                  <a:srgbClr val="8B949E"/>
-                </a:solidFill>
-                <a:latin typeface="Menlo"/>
-              </a:rPr>
-              <a:t> </a:t>
-            </a:r>
-            <a:r>
-              <a:rPr sz="1100">
-                <a:solidFill>
-                  <a:srgbClr val="3FB950"/>
-                </a:solidFill>
-                <a:latin typeface="Menlo"/>
-              </a:rPr>
-              <a:t> master </a:t>
-            </a:r>
-            <a:r>
-              <a:rPr sz="1100">
-                <a:solidFill>
-                  <a:srgbClr val="E5C07B"/>
-                </a:solidFill>
-                <a:latin typeface="Menlo"/>
-              </a:rPr>
-              <a:t>⚡</a:t>
-            </a:r>
-          </a:p>
-        </p:txBody>
-      </p:sp>
-      <p:sp>
-        <p:nvSpPr>
-          <p:cNvPr id="9" name="TextBox 8"/>
-          <p:cNvSpPr txBox="1"/>
-          <p:nvPr/>
-        </p:nvSpPr>
-        <p:spPr>
-          <a:xfrm>
-            <a:off x="274320" y="376257540600"/>
-            <a:ext cx="8595360" cy="228600"/>
-          </a:xfrm>
-          <a:prstGeom prst="rect">
-            <a:avLst/>
-          </a:prstGeom>
-          <a:noFill/>
-        </p:spPr>
-        <p:txBody>
-          <a:bodyPr wrap="none">
-            <a:spAutoFit/>
-          </a:bodyPr>
-          <a:lstStyle/>
-          <a:p/>
-          <a:p>
-            <a:r>
-              <a:rPr sz="1100">
-                <a:solidFill>
-                  <a:srgbClr val="8B949E"/>
-                </a:solidFill>
-                <a:latin typeface="Menlo"/>
-              </a:rPr>
-              <a:t>╰─</a:t>
-            </a:r>
-            <a:r>
-              <a:rPr sz="1200" b="1">
-                <a:solidFill>
-                  <a:srgbClr val="3FB950"/>
-                </a:solidFill>
-                <a:latin typeface="Menlo"/>
-              </a:rPr>
-              <a:t>❯ </a:t>
-            </a:r>
-            <a:r>
-              <a:rPr sz="1100">
-                <a:solidFill>
-                  <a:srgbClr val="C9D1D9"/>
-                </a:solidFill>
-                <a:latin typeface="Menlo"/>
-              </a:rPr>
-              <a:t>cat motivation.md</a:t>
-            </a:r>
-          </a:p>
-        </p:txBody>
-      </p:sp>
-      <p:sp>
-        <p:nvSpPr>
-          <p:cNvPr id="10" name="TextBox 9"/>
-          <p:cNvSpPr txBox="1"/>
-          <p:nvPr/>
-        </p:nvSpPr>
-        <p:spPr>
-          <a:xfrm>
-            <a:off x="548640" y="960120"/>
-            <a:ext cx="8046720" cy="548640"/>
-          </a:xfrm>
-          <a:prstGeom prst="rect">
-            <a:avLst/>
-          </a:prstGeom>
-          <a:noFill/>
-        </p:spPr>
-        <p:txBody>
-          <a:bodyPr wrap="none">
-            <a:spAutoFit/>
-          </a:bodyPr>
-          <a:lstStyle/>
-          <a:p>
-            <a:pPr>
-              <a:lnSpc>
-                <a:spcPct val="90000"/>
-              </a:lnSpc>
-              <a:defRPr sz="1000">
-                <a:solidFill>
-                  <a:srgbClr val="58A6FF"/>
-                </a:solidFill>
-                <a:latin typeface="Menlo"/>
-              </a:defRPr>
-            </a:pPr>
-            <a:r>
-              <a:t>╔══════════════════════════════════════╗</a:t>
-            </a:r>
-          </a:p>
-          <a:p>
-            <a:r>
-              <a:t>║               MOTIVATION               ║</a:t>
-            </a:r>
-          </a:p>
-          <a:p>
-            <a:r>
-              <a:t>╚══════════════════════════════════════╝</a:t>
-            </a:r>
-          </a:p>
-        </p:txBody>
-      </p:sp>
-      <p:sp>
-        <p:nvSpPr>
-          <p:cNvPr id="11" name="TextBox 10"/>
-          <p:cNvSpPr txBox="1"/>
-          <p:nvPr/>
-        </p:nvSpPr>
-        <p:spPr>
-          <a:xfrm>
-            <a:off x="548640" y="1737360"/>
-            <a:ext cx="8046720" cy="4389120"/>
-          </a:xfrm>
-          <a:prstGeom prst="rect">
-            <a:avLst/>
-          </a:prstGeom>
-          <a:noFill/>
-        </p:spPr>
-        <p:txBody>
-          <a:bodyPr wrap="none">
-            <a:spAutoFit/>
-          </a:bodyPr>
-          <a:lstStyle/>
-          <a:p>
-            <a:pPr>
-              <a:defRPr sz="1200">
-                <a:solidFill>
-                  <a:srgbClr val="D2A8FF"/>
-                </a:solidFill>
-                <a:latin typeface="Menlo"/>
-              </a:defRPr>
-            </a:pPr>
-            <a:r>
-              <a:t># Problem Statement</a:t>
-            </a:r>
-          </a:p>
-          <a:p>
-            <a:pPr>
-              <a:defRPr sz="1200">
-                <a:solidFill>
-                  <a:srgbClr val="C9D1D9"/>
-                </a:solidFill>
-                <a:latin typeface="Menlo"/>
-              </a:defRPr>
-            </a:pPr>
-            <a:r>
-              <a:t>  → DFT anharmonic calculations: expensive</a:t>
-            </a:r>
-          </a:p>
-          <a:p>
-            <a:pPr>
-              <a:defRPr sz="1200">
-                <a:solidFill>
-                  <a:srgbClr val="C9D1D9"/>
-                </a:solidFill>
-                <a:latin typeface="Menlo"/>
-              </a:defRPr>
-            </a:pPr>
-            <a:r>
-              <a:t>  → Hours to days per molecule</a:t>
-            </a:r>
-          </a:p>
-          <a:p>
-            <a:pPr>
-              <a:defRPr sz="1200">
-                <a:solidFill>
-                  <a:srgbClr val="C9D1D9"/>
-                </a:solidFill>
-                <a:latin typeface="Menlo"/>
-              </a:defRPr>
-            </a:pPr>
-            <a:r>
-              <a:t>  → Limits high-throughput applications</a:t>
-            </a:r>
-          </a:p>
-          <a:p>
-            <a:pPr>
-              <a:defRPr sz="1200">
-                <a:solidFill>
-                  <a:srgbClr val="C9D1D9"/>
-                </a:solidFill>
-                <a:latin typeface="Menlo"/>
-              </a:defRPr>
-            </a:pPr>
-          </a:p>
-          <a:p>
-            <a:pPr>
-              <a:defRPr sz="1200">
-                <a:solidFill>
-                  <a:srgbClr val="D2A8FF"/>
-                </a:solidFill>
-                <a:latin typeface="Menlo"/>
-              </a:defRPr>
-            </a:pPr>
-            <a:r>
-              <a:t># Our Solution</a:t>
-            </a:r>
-          </a:p>
-          <a:p>
-            <a:pPr>
-              <a:defRPr sz="1200">
-                <a:solidFill>
-                  <a:srgbClr val="3FB950"/>
-                </a:solidFill>
-                <a:latin typeface="Menlo"/>
-              </a:defRPr>
-            </a:pPr>
-            <a:r>
-              <a:t>  → ML potentials for fast components</a:t>
-            </a:r>
-          </a:p>
-          <a:p>
-            <a:pPr>
-              <a:defRPr sz="1200">
-                <a:solidFill>
-                  <a:srgbClr val="3FB950"/>
-                </a:solidFill>
-                <a:latin typeface="Menlo"/>
-              </a:defRPr>
-            </a:pPr>
-            <a:r>
-              <a:t>  → Gaussian for anharmonic corrections</a:t>
-            </a:r>
-          </a:p>
-          <a:p>
-            <a:pPr>
-              <a:defRPr sz="1200">
-                <a:solidFill>
-                  <a:srgbClr val="56B6C2"/>
-                </a:solidFill>
-                <a:latin typeface="Menlo"/>
-              </a:defRPr>
-            </a:pPr>
-            <a:r>
-              <a:t>  → ZMQ bridge for real-time communication</a:t>
-            </a:r>
-          </a:p>
-          <a:p>
-            <a:pPr>
-              <a:defRPr sz="1200">
-                <a:solidFill>
-                  <a:srgbClr val="C9D1D9"/>
-                </a:solidFill>
-                <a:latin typeface="Menlo"/>
-              </a:defRPr>
-            </a:pPr>
-          </a:p>
-          <a:p>
-            <a:pPr>
-              <a:defRPr sz="1200">
-                <a:solidFill>
-                  <a:srgbClr val="D2A8FF"/>
-                </a:solidFill>
-                <a:latin typeface="Menlo"/>
-              </a:defRPr>
-            </a:pPr>
-            <a:r>
-              <a:t># Impact</a:t>
-            </a:r>
-          </a:p>
-          <a:p>
-            <a:pPr>
-              <a:defRPr sz="1200">
-                <a:solidFill>
-                  <a:srgbClr val="E5C07B"/>
-                </a:solidFill>
-                <a:latin typeface="Menlo"/>
-              </a:defRPr>
-            </a:pPr>
-            <a:r>
-              <a:t>  ⚡ 10-100× computational speedup</a:t>
-            </a:r>
-          </a:p>
-          <a:p>
-            <a:pPr>
-              <a:defRPr sz="1200">
-                <a:solidFill>
-                  <a:srgbClr val="3FB950"/>
-                </a:solidFill>
-                <a:latin typeface="Menlo"/>
-              </a:defRPr>
-            </a:pPr>
-            <a:r>
-              <a:t>  ✓ Comparable accuracy to pure DFT</a:t>
-            </a:r>
-          </a:p>
-        </p:txBody>
-      </p:sp>
-      <p:sp>
-        <p:nvSpPr>
-          <p:cNvPr id="12" name="Rectangle 11"/>
-          <p:cNvSpPr/>
-          <p:nvPr/>
-        </p:nvSpPr>
-        <p:spPr>
-          <a:xfrm>
-            <a:off x="45720" y="6537960"/>
-            <a:ext cx="9052560" cy="228600"/>
-          </a:xfrm>
-          <a:prstGeom prst="rect">
-            <a:avLst/>
-          </a:prstGeom>
-          <a:solidFill>
-            <a:srgbClr val="161B22"/>
-          </a:solidFill>
-          <a:ln>
-            <a:noFill/>
-          </a:ln>
-        </p:spPr>
-        <p:style>
-          <a:lnRef idx="1">
-            <a:schemeClr val="accent1"/>
-          </a:lnRef>
-          <a:fillRef idx="3">
-            <a:schemeClr val="accent1"/>
-          </a:fillRef>
-          <a:effectRef idx="2">
-            <a:schemeClr val="accent1"/>
-          </a:effectRef>
-          <a:fontRef idx="minor">
-            <a:schemeClr val="lt1"/>
-          </a:fontRef>
-        </p:style>
-        <p:txBody>
-          <a:bodyPr rtlCol="0" anchor="ctr"/>
-          <a:lstStyle/>
-          <a:p>
-            <a:pPr algn="ctr"/>
-          </a:p>
-        </p:txBody>
-      </p:sp>
-      <p:sp>
-        <p:nvSpPr>
-          <p:cNvPr id="13" name="TextBox 12"/>
-          <p:cNvSpPr txBox="1"/>
-          <p:nvPr/>
-        </p:nvSpPr>
-        <p:spPr>
-          <a:xfrm>
-            <a:off x="274320" y="6565392"/>
-            <a:ext cx="8595360" cy="182880"/>
-          </a:xfrm>
-          <a:prstGeom prst="rect">
-            <a:avLst/>
-          </a:prstGeom>
-          <a:noFill/>
-        </p:spPr>
-        <p:txBody>
-          <a:bodyPr wrap="none">
-            <a:spAutoFit/>
-          </a:bodyPr>
-          <a:lstStyle/>
-          <a:p>
             <a:pPr>
               <a:defRPr sz="900">
                 <a:solidFill>
                   <a:srgbClr val="C9D1D9"/>
                 </a:solidFill>
-                <a:latin typeface="Menlo"/>
+                <a:latin typeface="Meslo Nerd Font"/>
               </a:defRPr>
             </a:pPr>
             <a:r>
@@ -4699,173 +3936,292 @@
       <p:grpSpPr/>
       <p:sp>
         <p:nvSpPr>
-          <p:cNvPr id="2" name="Rectangle 1"/>
-          <p:cNvSpPr/>
+          <p:cNvPr id="2" name="TextBox 1"/>
+          <p:cNvSpPr txBox="1"/>
           <p:nvPr/>
         </p:nvSpPr>
         <p:spPr>
           <a:xfrm>
-            <a:off x="0" y="0"/>
-            <a:ext cx="9144000" cy="45720"/>
+            <a:off x="457200" y="418063680000"/>
+            <a:ext cx="8229600" cy="228600"/>
           </a:xfrm>
           <a:prstGeom prst="rect">
             <a:avLst/>
           </a:prstGeom>
-          <a:solidFill>
-            <a:srgbClr val="30363D"/>
-          </a:solidFill>
-          <a:ln>
-            <a:noFill/>
-          </a:ln>
+          <a:noFill/>
         </p:spPr>
-        <p:style>
-          <a:lnRef idx="1">
-            <a:schemeClr val="accent1"/>
-          </a:lnRef>
-          <a:fillRef idx="3">
-            <a:schemeClr val="accent1"/>
-          </a:fillRef>
-          <a:effectRef idx="2">
-            <a:schemeClr val="accent1"/>
-          </a:effectRef>
-          <a:fontRef idx="minor">
-            <a:schemeClr val="lt1"/>
-          </a:fontRef>
-        </p:style>
-        <p:txBody>
-          <a:bodyPr rtlCol="0" anchor="ctr"/>
-          <a:lstStyle/>
-          <a:p>
-            <a:pPr algn="ctr"/>
-          </a:p>
-        </p:txBody>
-      </p:sp>
-      <p:sp>
-        <p:nvSpPr>
-          <p:cNvPr id="3" name="Rectangle 2"/>
-          <p:cNvSpPr/>
+        <p:txBody>
+          <a:bodyPr wrap="none">
+            <a:spAutoFit/>
+          </a:bodyPr>
+          <a:lstStyle/>
+          <a:p/>
+          <a:p>
+            <a:r>
+              <a:rPr sz="1100">
+                <a:solidFill>
+                  <a:srgbClr val="8B949E"/>
+                </a:solidFill>
+                <a:latin typeface="Meslo Nerd Font"/>
+              </a:rPr>
+              <a:t>╭─</a:t>
+            </a:r>
+            <a:r>
+              <a:rPr sz="1100" b="1">
+                <a:solidFill>
+                  <a:srgbClr val="56B6C2"/>
+                </a:solidFill>
+                <a:latin typeface="Meslo Nerd Font"/>
+              </a:rPr>
+              <a:t>  mot@rs1-c724 </a:t>
+            </a:r>
+            <a:r>
+              <a:rPr sz="1100">
+                <a:solidFill>
+                  <a:srgbClr val="8B949E"/>
+                </a:solidFill>
+                <a:latin typeface="Meslo Nerd Font"/>
+              </a:rPr>
+              <a:t> </a:t>
+            </a:r>
+            <a:r>
+              <a:rPr sz="1100">
+                <a:solidFill>
+                  <a:srgbClr val="D2A8FF"/>
+                </a:solidFill>
+                <a:latin typeface="Meslo Nerd Font"/>
+              </a:rPr>
+              <a:t> ~/presentation </a:t>
+            </a:r>
+            <a:r>
+              <a:rPr sz="1100">
+                <a:solidFill>
+                  <a:srgbClr val="8B949E"/>
+                </a:solidFill>
+                <a:latin typeface="Meslo Nerd Font"/>
+              </a:rPr>
+              <a:t> </a:t>
+            </a:r>
+            <a:r>
+              <a:rPr sz="1100">
+                <a:solidFill>
+                  <a:srgbClr val="3FB950"/>
+                </a:solidFill>
+                <a:latin typeface="Meslo Nerd Font"/>
+              </a:rPr>
+              <a:t> master </a:t>
+            </a:r>
+            <a:r>
+              <a:rPr sz="1100">
+                <a:solidFill>
+                  <a:srgbClr val="E5C07B"/>
+                </a:solidFill>
+                <a:latin typeface="Meslo Nerd Font"/>
+              </a:rPr>
+              <a:t>⚡</a:t>
+            </a:r>
+          </a:p>
+        </p:txBody>
+      </p:sp>
+      <p:sp>
+        <p:nvSpPr>
+          <p:cNvPr id="3" name="TextBox 2"/>
+          <p:cNvSpPr txBox="1"/>
           <p:nvPr/>
         </p:nvSpPr>
         <p:spPr>
           <a:xfrm>
-            <a:off x="0" y="6812280"/>
-            <a:ext cx="9144000" cy="45720"/>
+            <a:off x="457200" y="418063908600"/>
+            <a:ext cx="8229600" cy="228600"/>
           </a:xfrm>
           <a:prstGeom prst="rect">
             <a:avLst/>
           </a:prstGeom>
-          <a:solidFill>
-            <a:srgbClr val="30363D"/>
-          </a:solidFill>
-          <a:ln>
-            <a:noFill/>
-          </a:ln>
+          <a:noFill/>
         </p:spPr>
-        <p:style>
-          <a:lnRef idx="1">
-            <a:schemeClr val="accent1"/>
-          </a:lnRef>
-          <a:fillRef idx="3">
-            <a:schemeClr val="accent1"/>
-          </a:fillRef>
-          <a:effectRef idx="2">
-            <a:schemeClr val="accent1"/>
-          </a:effectRef>
-          <a:fontRef idx="minor">
-            <a:schemeClr val="lt1"/>
-          </a:fontRef>
-        </p:style>
-        <p:txBody>
-          <a:bodyPr rtlCol="0" anchor="ctr"/>
-          <a:lstStyle/>
-          <a:p>
-            <a:pPr algn="ctr"/>
-          </a:p>
-        </p:txBody>
-      </p:sp>
-      <p:sp>
-        <p:nvSpPr>
-          <p:cNvPr id="4" name="Rectangle 3"/>
-          <p:cNvSpPr/>
+        <p:txBody>
+          <a:bodyPr wrap="none">
+            <a:spAutoFit/>
+          </a:bodyPr>
+          <a:lstStyle/>
+          <a:p/>
+          <a:p>
+            <a:r>
+              <a:rPr sz="1100">
+                <a:solidFill>
+                  <a:srgbClr val="8B949E"/>
+                </a:solidFill>
+                <a:latin typeface="Meslo Nerd Font"/>
+              </a:rPr>
+              <a:t>╰─</a:t>
+            </a:r>
+            <a:r>
+              <a:rPr sz="1200" b="1">
+                <a:solidFill>
+                  <a:srgbClr val="3FB950"/>
+                </a:solidFill>
+                <a:latin typeface="Meslo Nerd Font"/>
+              </a:rPr>
+              <a:t>❯ </a:t>
+            </a:r>
+            <a:r>
+              <a:rPr sz="1100">
+                <a:solidFill>
+                  <a:srgbClr val="C9D1D9"/>
+                </a:solidFill>
+                <a:latin typeface="Meslo Nerd Font"/>
+              </a:rPr>
+              <a:t>ls -la architecture/</a:t>
+            </a:r>
+          </a:p>
+        </p:txBody>
+      </p:sp>
+      <p:sp>
+        <p:nvSpPr>
+          <p:cNvPr id="4" name="TextBox 3"/>
+          <p:cNvSpPr txBox="1"/>
           <p:nvPr/>
         </p:nvSpPr>
         <p:spPr>
           <a:xfrm>
-            <a:off x="0" y="0"/>
-            <a:ext cx="45720" cy="6858000"/>
+            <a:off x="731520" y="1097280"/>
+            <a:ext cx="7680960" cy="548640"/>
           </a:xfrm>
           <a:prstGeom prst="rect">
             <a:avLst/>
           </a:prstGeom>
-          <a:solidFill>
-            <a:srgbClr val="30363D"/>
-          </a:solidFill>
-          <a:ln>
-            <a:noFill/>
-          </a:ln>
+          <a:noFill/>
         </p:spPr>
-        <p:style>
-          <a:lnRef idx="1">
-            <a:schemeClr val="accent1"/>
-          </a:lnRef>
-          <a:fillRef idx="3">
-            <a:schemeClr val="accent1"/>
-          </a:fillRef>
-          <a:effectRef idx="2">
-            <a:schemeClr val="accent1"/>
-          </a:effectRef>
-          <a:fontRef idx="minor">
-            <a:schemeClr val="lt1"/>
-          </a:fontRef>
-        </p:style>
-        <p:txBody>
-          <a:bodyPr rtlCol="0" anchor="ctr"/>
-          <a:lstStyle/>
-          <a:p>
-            <a:pPr algn="ctr"/>
-          </a:p>
-        </p:txBody>
-      </p:sp>
-      <p:sp>
-        <p:nvSpPr>
-          <p:cNvPr id="5" name="Rectangle 4"/>
-          <p:cNvSpPr/>
+        <p:txBody>
+          <a:bodyPr wrap="none">
+            <a:spAutoFit/>
+          </a:bodyPr>
+          <a:lstStyle/>
+          <a:p>
+            <a:pPr>
+              <a:lnSpc>
+                <a:spcPct val="90000"/>
+              </a:lnSpc>
+              <a:defRPr sz="1000">
+                <a:solidFill>
+                  <a:srgbClr val="56B6C2"/>
+                </a:solidFill>
+                <a:latin typeface="Meslo Nerd Font"/>
+              </a:defRPr>
+            </a:pPr>
+            <a:r>
+              <a:t>╔═══════════════════════════════╗</a:t>
+            </a:r>
+          </a:p>
+          <a:p>
+            <a:r>
+              <a:t>║     SYSTEM ARCHITECTURE       ║</a:t>
+            </a:r>
+          </a:p>
+          <a:p>
+            <a:r>
+              <a:t>╚═══════════════════════════════╝</a:t>
+            </a:r>
+          </a:p>
+        </p:txBody>
+      </p:sp>
+      <p:sp>
+        <p:nvSpPr>
+          <p:cNvPr id="5" name="TextBox 4"/>
+          <p:cNvSpPr txBox="1"/>
           <p:nvPr/>
         </p:nvSpPr>
         <p:spPr>
           <a:xfrm>
-            <a:off x="9098280" y="0"/>
-            <a:ext cx="45720" cy="6858000"/>
+            <a:off x="731520" y="1828800"/>
+            <a:ext cx="7680960" cy="4389120"/>
           </a:xfrm>
           <a:prstGeom prst="rect">
             <a:avLst/>
           </a:prstGeom>
-          <a:solidFill>
-            <a:srgbClr val="30363D"/>
-          </a:solidFill>
-          <a:ln>
-            <a:noFill/>
-          </a:ln>
+          <a:noFill/>
         </p:spPr>
-        <p:style>
-          <a:lnRef idx="1">
-            <a:schemeClr val="accent1"/>
-          </a:lnRef>
-          <a:fillRef idx="3">
-            <a:schemeClr val="accent1"/>
-          </a:fillRef>
-          <a:effectRef idx="2">
-            <a:schemeClr val="accent1"/>
-          </a:effectRef>
-          <a:fontRef idx="minor">
-            <a:schemeClr val="lt1"/>
-          </a:fontRef>
-        </p:style>
-        <p:txBody>
-          <a:bodyPr rtlCol="0" anchor="ctr"/>
-          <a:lstStyle/>
-          <a:p>
-            <a:pPr algn="ctr"/>
+        <p:txBody>
+          <a:bodyPr wrap="none">
+            <a:spAutoFit/>
+          </a:bodyPr>
+          <a:lstStyle/>
+          <a:p>
+            <a:pPr>
+              <a:lnSpc>
+                <a:spcPct val="130000"/>
+              </a:lnSpc>
+              <a:defRPr sz="1100">
+                <a:solidFill>
+                  <a:srgbClr val="C9D1D9"/>
+                </a:solidFill>
+                <a:latin typeface="Meslo Nerd Font"/>
+              </a:defRPr>
+            </a:pPr>
+            <a:r>
+              <a:t>total 5</a:t>
+            </a:r>
+          </a:p>
+          <a:p>
+            <a:r>
+              <a:t>drwxr-xr-x  5 mot  group   160  Nov 15 12:00  .</a:t>
+            </a:r>
+          </a:p>
+          <a:p>
+            <a:r>
+              <a:t>drwxr-xr-x 12 mot  group   384  Nov 15 11:00  ..</a:t>
+            </a:r>
+          </a:p>
+          <a:p>
+            <a:r>
+              <a:t>-rw-r--r--  1 mot  group  2.1K  Nov 15 10:30  workflow.png</a:t>
+            </a:r>
+          </a:p>
+          <a:p>
+            <a:r>
+              <a:t>-rw-r--r--  1 mot  group  3.4K  Nov 15 10:31  zmq_bridge.png</a:t>
+            </a:r>
+          </a:p>
+          <a:p>
+            <a:r>
+              <a:t>-rw-r--r--  1 mot  group  1.8K  Nov 15 10:32  module_swap.png</a:t>
+            </a:r>
+          </a:p>
+          <a:p/>
+          <a:p>
+            <a:r>
+              <a:t>📁 Input → 🔧 MACE Opt → ⚛️  Gaussian</a:t>
+            </a:r>
+          </a:p>
+          <a:p>
+            <a:r>
+              <a:t>                            ↓</a:t>
+            </a:r>
+          </a:p>
+          <a:p>
+            <a:r>
+              <a:t>                      🔌 ZMQ Bridge</a:t>
+            </a:r>
+          </a:p>
+          <a:p>
+            <a:r>
+              <a:t>                            ↓</a:t>
+            </a:r>
+          </a:p>
+          <a:p>
+            <a:r>
+              <a:t>                        🤖 ML Dipole</a:t>
+            </a:r>
+          </a:p>
+          <a:p>
+            <a:r>
+              <a:t>                            ↓</a:t>
+            </a:r>
+          </a:p>
+          <a:p>
+            <a:r>
+              <a:t>          📊 Analysis → 📄 Report</a:t>
+            </a:r>
           </a:p>
         </p:txBody>
       </p:sp>
@@ -4877,8 +4233,8 @@
         </p:nvSpPr>
         <p:spPr>
           <a:xfrm>
-            <a:off x="45720" y="73152"/>
-            <a:ext cx="9052560" cy="228600"/>
+            <a:off x="0" y="6629400"/>
+            <a:ext cx="9144000" cy="228600"/>
           </a:xfrm>
           <a:prstGeom prst="rect">
             <a:avLst/>
@@ -4920,7 +4276,7 @@
         </p:nvSpPr>
         <p:spPr>
           <a:xfrm>
-            <a:off x="457200" y="100584"/>
+            <a:off x="457200" y="6656832"/>
             <a:ext cx="8229600" cy="182880"/>
           </a:xfrm>
           <a:prstGeom prst="rect">
@@ -4934,382 +4290,12 @@
           </a:bodyPr>
           <a:lstStyle/>
           <a:p>
-            <a:pPr algn="ctr">
-              <a:defRPr sz="800">
-                <a:solidFill>
-                  <a:srgbClr val="8B949E"/>
-                </a:solidFill>
-                <a:latin typeface="Menlo"/>
-              </a:defRPr>
-            </a:pPr>
-            <a:r>
-              <a:t>presentation — mot@rs1-c724</a:t>
-            </a:r>
-          </a:p>
-        </p:txBody>
-      </p:sp>
-      <p:sp>
-        <p:nvSpPr>
-          <p:cNvPr id="8" name="TextBox 7"/>
-          <p:cNvSpPr txBox="1"/>
-          <p:nvPr/>
-        </p:nvSpPr>
-        <p:spPr>
-          <a:xfrm>
-            <a:off x="274320" y="376257312000"/>
-            <a:ext cx="8595360" cy="228600"/>
-          </a:xfrm>
-          <a:prstGeom prst="rect">
-            <a:avLst/>
-          </a:prstGeom>
-          <a:noFill/>
-        </p:spPr>
-        <p:txBody>
-          <a:bodyPr wrap="none">
-            <a:spAutoFit/>
-          </a:bodyPr>
-          <a:lstStyle/>
-          <a:p/>
-          <a:p>
-            <a:r>
-              <a:rPr sz="1100">
-                <a:solidFill>
-                  <a:srgbClr val="8B949E"/>
-                </a:solidFill>
-                <a:latin typeface="Menlo"/>
-              </a:rPr>
-              <a:t>╭─</a:t>
-            </a:r>
-            <a:r>
-              <a:rPr sz="1100" b="1">
-                <a:solidFill>
-                  <a:srgbClr val="56B6C2"/>
-                </a:solidFill>
-                <a:latin typeface="Menlo"/>
-              </a:rPr>
-              <a:t>  mot@rs1-c724 </a:t>
-            </a:r>
-            <a:r>
-              <a:rPr sz="1100">
-                <a:solidFill>
-                  <a:srgbClr val="8B949E"/>
-                </a:solidFill>
-                <a:latin typeface="Menlo"/>
-              </a:rPr>
-              <a:t> </a:t>
-            </a:r>
-            <a:r>
-              <a:rPr sz="1100">
-                <a:solidFill>
-                  <a:srgbClr val="D2A8FF"/>
-                </a:solidFill>
-                <a:latin typeface="Menlo"/>
-              </a:rPr>
-              <a:t> ~/presentation </a:t>
-            </a:r>
-            <a:r>
-              <a:rPr sz="1100">
-                <a:solidFill>
-                  <a:srgbClr val="8B949E"/>
-                </a:solidFill>
-                <a:latin typeface="Menlo"/>
-              </a:rPr>
-              <a:t> </a:t>
-            </a:r>
-            <a:r>
-              <a:rPr sz="1100">
-                <a:solidFill>
-                  <a:srgbClr val="3FB950"/>
-                </a:solidFill>
-                <a:latin typeface="Menlo"/>
-              </a:rPr>
-              <a:t> master </a:t>
-            </a:r>
-            <a:r>
-              <a:rPr sz="1100">
-                <a:solidFill>
-                  <a:srgbClr val="E5C07B"/>
-                </a:solidFill>
-                <a:latin typeface="Menlo"/>
-              </a:rPr>
-              <a:t>⚡</a:t>
-            </a:r>
-          </a:p>
-        </p:txBody>
-      </p:sp>
-      <p:sp>
-        <p:nvSpPr>
-          <p:cNvPr id="9" name="TextBox 8"/>
-          <p:cNvSpPr txBox="1"/>
-          <p:nvPr/>
-        </p:nvSpPr>
-        <p:spPr>
-          <a:xfrm>
-            <a:off x="274320" y="376257540600"/>
-            <a:ext cx="8595360" cy="228600"/>
-          </a:xfrm>
-          <a:prstGeom prst="rect">
-            <a:avLst/>
-          </a:prstGeom>
-          <a:noFill/>
-        </p:spPr>
-        <p:txBody>
-          <a:bodyPr wrap="none">
-            <a:spAutoFit/>
-          </a:bodyPr>
-          <a:lstStyle/>
-          <a:p/>
-          <a:p>
-            <a:r>
-              <a:rPr sz="1100">
-                <a:solidFill>
-                  <a:srgbClr val="8B949E"/>
-                </a:solidFill>
-                <a:latin typeface="Menlo"/>
-              </a:rPr>
-              <a:t>╰─</a:t>
-            </a:r>
-            <a:r>
-              <a:rPr sz="1200" b="1">
-                <a:solidFill>
-                  <a:srgbClr val="3FB950"/>
-                </a:solidFill>
-                <a:latin typeface="Menlo"/>
-              </a:rPr>
-              <a:t>❯ </a:t>
-            </a:r>
-            <a:r>
-              <a:rPr sz="1100">
-                <a:solidFill>
-                  <a:srgbClr val="C9D1D9"/>
-                </a:solidFill>
-                <a:latin typeface="Menlo"/>
-              </a:rPr>
-              <a:t>ls -la architecture/</a:t>
-            </a:r>
-          </a:p>
-        </p:txBody>
-      </p:sp>
-      <p:sp>
-        <p:nvSpPr>
-          <p:cNvPr id="10" name="TextBox 9"/>
-          <p:cNvSpPr txBox="1"/>
-          <p:nvPr/>
-        </p:nvSpPr>
-        <p:spPr>
-          <a:xfrm>
-            <a:off x="548640" y="960120"/>
-            <a:ext cx="8046720" cy="548640"/>
-          </a:xfrm>
-          <a:prstGeom prst="rect">
-            <a:avLst/>
-          </a:prstGeom>
-          <a:noFill/>
-        </p:spPr>
-        <p:txBody>
-          <a:bodyPr wrap="none">
-            <a:spAutoFit/>
-          </a:bodyPr>
-          <a:lstStyle/>
-          <a:p>
-            <a:pPr>
-              <a:lnSpc>
-                <a:spcPct val="90000"/>
-              </a:lnSpc>
-              <a:defRPr sz="1000">
-                <a:solidFill>
-                  <a:srgbClr val="56B6C2"/>
-                </a:solidFill>
-                <a:latin typeface="Menlo"/>
-              </a:defRPr>
-            </a:pPr>
-            <a:r>
-              <a:t>╔═══════════════════════════════╗</a:t>
-            </a:r>
-          </a:p>
-          <a:p>
-            <a:r>
-              <a:t>║     SYSTEM ARCHITECTURE       ║</a:t>
-            </a:r>
-          </a:p>
-          <a:p>
-            <a:r>
-              <a:t>╚═══════════════════════════════╝</a:t>
-            </a:r>
-          </a:p>
-        </p:txBody>
-      </p:sp>
-      <p:sp>
-        <p:nvSpPr>
-          <p:cNvPr id="11" name="TextBox 10"/>
-          <p:cNvSpPr txBox="1"/>
-          <p:nvPr/>
-        </p:nvSpPr>
-        <p:spPr>
-          <a:xfrm>
-            <a:off x="548640" y="1691640"/>
-            <a:ext cx="8046720" cy="4480560"/>
-          </a:xfrm>
-          <a:prstGeom prst="rect">
-            <a:avLst/>
-          </a:prstGeom>
-          <a:noFill/>
-        </p:spPr>
-        <p:txBody>
-          <a:bodyPr wrap="none">
-            <a:spAutoFit/>
-          </a:bodyPr>
-          <a:lstStyle/>
-          <a:p>
-            <a:pPr>
-              <a:lnSpc>
-                <a:spcPct val="130000"/>
-              </a:lnSpc>
-              <a:defRPr sz="1100">
-                <a:solidFill>
-                  <a:srgbClr val="C9D1D9"/>
-                </a:solidFill>
-                <a:latin typeface="Menlo"/>
-              </a:defRPr>
-            </a:pPr>
-            <a:r>
-              <a:t>total 5</a:t>
-            </a:r>
-          </a:p>
-          <a:p>
-            <a:r>
-              <a:t>drwxr-xr-x  5 mot  group   160  Nov 15 12:00  .</a:t>
-            </a:r>
-          </a:p>
-          <a:p>
-            <a:r>
-              <a:t>drwxr-xr-x 12 mot  group   384  Nov 15 11:00  ..</a:t>
-            </a:r>
-          </a:p>
-          <a:p>
-            <a:r>
-              <a:t>-rw-r--r--  1 mot  group  2.1K  Nov 15 10:30  workflow.png</a:t>
-            </a:r>
-          </a:p>
-          <a:p>
-            <a:r>
-              <a:t>-rw-r--r--  1 mot  group  3.4K  Nov 15 10:31  zmq_bridge.png</a:t>
-            </a:r>
-          </a:p>
-          <a:p>
-            <a:r>
-              <a:t>-rw-r--r--  1 mot  group  1.8K  Nov 15 10:32  module_swap.png</a:t>
-            </a:r>
-          </a:p>
-          <a:p/>
-          <a:p>
-            <a:r>
-              <a:t>📁 Input → 🔧 MACE Opt → ⚛️  Gaussian</a:t>
-            </a:r>
-          </a:p>
-          <a:p>
-            <a:r>
-              <a:t>                            ↓</a:t>
-            </a:r>
-          </a:p>
-          <a:p>
-            <a:r>
-              <a:t>                      🔌 ZMQ Bridge</a:t>
-            </a:r>
-          </a:p>
-          <a:p>
-            <a:r>
-              <a:t>                            ↓</a:t>
-            </a:r>
-          </a:p>
-          <a:p>
-            <a:r>
-              <a:t>                        🤖 ML Dipole</a:t>
-            </a:r>
-          </a:p>
-          <a:p>
-            <a:r>
-              <a:t>                            ↓</a:t>
-            </a:r>
-          </a:p>
-          <a:p>
-            <a:r>
-              <a:t>          📊 Analysis → 📄 Report</a:t>
-            </a:r>
-          </a:p>
-        </p:txBody>
-      </p:sp>
-      <p:sp>
-        <p:nvSpPr>
-          <p:cNvPr id="12" name="Rectangle 11"/>
-          <p:cNvSpPr/>
-          <p:nvPr/>
-        </p:nvSpPr>
-        <p:spPr>
-          <a:xfrm>
-            <a:off x="45720" y="6537960"/>
-            <a:ext cx="9052560" cy="228600"/>
-          </a:xfrm>
-          <a:prstGeom prst="rect">
-            <a:avLst/>
-          </a:prstGeom>
-          <a:solidFill>
-            <a:srgbClr val="161B22"/>
-          </a:solidFill>
-          <a:ln>
-            <a:noFill/>
-          </a:ln>
-        </p:spPr>
-        <p:style>
-          <a:lnRef idx="1">
-            <a:schemeClr val="accent1"/>
-          </a:lnRef>
-          <a:fillRef idx="3">
-            <a:schemeClr val="accent1"/>
-          </a:fillRef>
-          <a:effectRef idx="2">
-            <a:schemeClr val="accent1"/>
-          </a:effectRef>
-          <a:fontRef idx="minor">
-            <a:schemeClr val="lt1"/>
-          </a:fontRef>
-        </p:style>
-        <p:txBody>
-          <a:bodyPr rtlCol="0" anchor="ctr"/>
-          <a:lstStyle/>
-          <a:p>
-            <a:pPr algn="ctr"/>
-          </a:p>
-        </p:txBody>
-      </p:sp>
-      <p:sp>
-        <p:nvSpPr>
-          <p:cNvPr id="13" name="TextBox 12"/>
-          <p:cNvSpPr txBox="1"/>
-          <p:nvPr/>
-        </p:nvSpPr>
-        <p:spPr>
-          <a:xfrm>
-            <a:off x="274320" y="6565392"/>
-            <a:ext cx="8595360" cy="182880"/>
-          </a:xfrm>
-          <a:prstGeom prst="rect">
-            <a:avLst/>
-          </a:prstGeom>
-          <a:noFill/>
-        </p:spPr>
-        <p:txBody>
-          <a:bodyPr wrap="none">
-            <a:spAutoFit/>
-          </a:bodyPr>
-          <a:lstStyle/>
-          <a:p>
             <a:pPr>
               <a:defRPr sz="900">
                 <a:solidFill>
                   <a:srgbClr val="C9D1D9"/>
                 </a:solidFill>
-                <a:latin typeface="Menlo"/>
+                <a:latin typeface="Meslo Nerd Font"/>
               </a:defRPr>
             </a:pPr>
             <a:r>
@@ -5346,173 +4332,309 @@
       <p:grpSpPr/>
       <p:sp>
         <p:nvSpPr>
-          <p:cNvPr id="2" name="Rectangle 1"/>
-          <p:cNvSpPr/>
+          <p:cNvPr id="2" name="TextBox 1"/>
+          <p:cNvSpPr txBox="1"/>
           <p:nvPr/>
         </p:nvSpPr>
         <p:spPr>
           <a:xfrm>
-            <a:off x="0" y="0"/>
-            <a:ext cx="9144000" cy="45720"/>
+            <a:off x="457200" y="418063680000"/>
+            <a:ext cx="8229600" cy="228600"/>
           </a:xfrm>
           <a:prstGeom prst="rect">
             <a:avLst/>
           </a:prstGeom>
-          <a:solidFill>
-            <a:srgbClr val="30363D"/>
-          </a:solidFill>
-          <a:ln>
-            <a:noFill/>
-          </a:ln>
+          <a:noFill/>
         </p:spPr>
-        <p:style>
-          <a:lnRef idx="1">
-            <a:schemeClr val="accent1"/>
-          </a:lnRef>
-          <a:fillRef idx="3">
-            <a:schemeClr val="accent1"/>
-          </a:fillRef>
-          <a:effectRef idx="2">
-            <a:schemeClr val="accent1"/>
-          </a:effectRef>
-          <a:fontRef idx="minor">
-            <a:schemeClr val="lt1"/>
-          </a:fontRef>
-        </p:style>
-        <p:txBody>
-          <a:bodyPr rtlCol="0" anchor="ctr"/>
-          <a:lstStyle/>
-          <a:p>
-            <a:pPr algn="ctr"/>
-          </a:p>
-        </p:txBody>
-      </p:sp>
-      <p:sp>
-        <p:nvSpPr>
-          <p:cNvPr id="3" name="Rectangle 2"/>
-          <p:cNvSpPr/>
+        <p:txBody>
+          <a:bodyPr wrap="none">
+            <a:spAutoFit/>
+          </a:bodyPr>
+          <a:lstStyle/>
+          <a:p/>
+          <a:p>
+            <a:r>
+              <a:rPr sz="1100">
+                <a:solidFill>
+                  <a:srgbClr val="8B949E"/>
+                </a:solidFill>
+                <a:latin typeface="Meslo Nerd Font"/>
+              </a:rPr>
+              <a:t>╭─</a:t>
+            </a:r>
+            <a:r>
+              <a:rPr sz="1100" b="1">
+                <a:solidFill>
+                  <a:srgbClr val="56B6C2"/>
+                </a:solidFill>
+                <a:latin typeface="Meslo Nerd Font"/>
+              </a:rPr>
+              <a:t>  mot@rs1-c724 </a:t>
+            </a:r>
+            <a:r>
+              <a:rPr sz="1100">
+                <a:solidFill>
+                  <a:srgbClr val="8B949E"/>
+                </a:solidFill>
+                <a:latin typeface="Meslo Nerd Font"/>
+              </a:rPr>
+              <a:t> </a:t>
+            </a:r>
+            <a:r>
+              <a:rPr sz="1100">
+                <a:solidFill>
+                  <a:srgbClr val="D2A8FF"/>
+                </a:solidFill>
+                <a:latin typeface="Meslo Nerd Font"/>
+              </a:rPr>
+              <a:t> ~/presentation </a:t>
+            </a:r>
+            <a:r>
+              <a:rPr sz="1100">
+                <a:solidFill>
+                  <a:srgbClr val="8B949E"/>
+                </a:solidFill>
+                <a:latin typeface="Meslo Nerd Font"/>
+              </a:rPr>
+              <a:t> </a:t>
+            </a:r>
+            <a:r>
+              <a:rPr sz="1100">
+                <a:solidFill>
+                  <a:srgbClr val="3FB950"/>
+                </a:solidFill>
+                <a:latin typeface="Meslo Nerd Font"/>
+              </a:rPr>
+              <a:t> master </a:t>
+            </a:r>
+            <a:r>
+              <a:rPr sz="1100">
+                <a:solidFill>
+                  <a:srgbClr val="E5C07B"/>
+                </a:solidFill>
+                <a:latin typeface="Meslo Nerd Font"/>
+              </a:rPr>
+              <a:t>⚡</a:t>
+            </a:r>
+          </a:p>
+        </p:txBody>
+      </p:sp>
+      <p:sp>
+        <p:nvSpPr>
+          <p:cNvPr id="3" name="TextBox 2"/>
+          <p:cNvSpPr txBox="1"/>
           <p:nvPr/>
         </p:nvSpPr>
         <p:spPr>
           <a:xfrm>
-            <a:off x="0" y="6812280"/>
-            <a:ext cx="9144000" cy="45720"/>
+            <a:off x="457200" y="418063908600"/>
+            <a:ext cx="8229600" cy="228600"/>
           </a:xfrm>
           <a:prstGeom prst="rect">
             <a:avLst/>
           </a:prstGeom>
-          <a:solidFill>
-            <a:srgbClr val="30363D"/>
-          </a:solidFill>
-          <a:ln>
-            <a:noFill/>
-          </a:ln>
+          <a:noFill/>
         </p:spPr>
-        <p:style>
-          <a:lnRef idx="1">
-            <a:schemeClr val="accent1"/>
-          </a:lnRef>
-          <a:fillRef idx="3">
-            <a:schemeClr val="accent1"/>
-          </a:fillRef>
-          <a:effectRef idx="2">
-            <a:schemeClr val="accent1"/>
-          </a:effectRef>
-          <a:fontRef idx="minor">
-            <a:schemeClr val="lt1"/>
-          </a:fontRef>
-        </p:style>
-        <p:txBody>
-          <a:bodyPr rtlCol="0" anchor="ctr"/>
-          <a:lstStyle/>
-          <a:p>
-            <a:pPr algn="ctr"/>
-          </a:p>
-        </p:txBody>
-      </p:sp>
-      <p:sp>
-        <p:nvSpPr>
-          <p:cNvPr id="4" name="Rectangle 3"/>
-          <p:cNvSpPr/>
+        <p:txBody>
+          <a:bodyPr wrap="none">
+            <a:spAutoFit/>
+          </a:bodyPr>
+          <a:lstStyle/>
+          <a:p/>
+          <a:p>
+            <a:r>
+              <a:rPr sz="1100">
+                <a:solidFill>
+                  <a:srgbClr val="8B949E"/>
+                </a:solidFill>
+                <a:latin typeface="Meslo Nerd Font"/>
+              </a:rPr>
+              <a:t>╰─</a:t>
+            </a:r>
+            <a:r>
+              <a:rPr sz="1200" b="1">
+                <a:solidFill>
+                  <a:srgbClr val="3FB950"/>
+                </a:solidFill>
+                <a:latin typeface="Meslo Nerd Font"/>
+              </a:rPr>
+              <a:t>❯ </a:t>
+            </a:r>
+            <a:r>
+              <a:rPr sz="1100">
+                <a:solidFill>
+                  <a:srgbClr val="C9D1D9"/>
+                </a:solidFill>
+                <a:latin typeface="Meslo Nerd Font"/>
+              </a:rPr>
+              <a:t>git diff --stat dft ml</a:t>
+            </a:r>
+          </a:p>
+        </p:txBody>
+      </p:sp>
+      <p:sp>
+        <p:nvSpPr>
+          <p:cNvPr id="4" name="TextBox 3"/>
+          <p:cNvSpPr txBox="1"/>
           <p:nvPr/>
         </p:nvSpPr>
         <p:spPr>
           <a:xfrm>
-            <a:off x="0" y="0"/>
-            <a:ext cx="45720" cy="6858000"/>
+            <a:off x="731520" y="1097280"/>
+            <a:ext cx="7680960" cy="548640"/>
           </a:xfrm>
           <a:prstGeom prst="rect">
             <a:avLst/>
           </a:prstGeom>
-          <a:solidFill>
-            <a:srgbClr val="30363D"/>
-          </a:solidFill>
-          <a:ln>
-            <a:noFill/>
-          </a:ln>
+          <a:noFill/>
         </p:spPr>
-        <p:style>
-          <a:lnRef idx="1">
-            <a:schemeClr val="accent1"/>
-          </a:lnRef>
-          <a:fillRef idx="3">
-            <a:schemeClr val="accent1"/>
-          </a:fillRef>
-          <a:effectRef idx="2">
-            <a:schemeClr val="accent1"/>
-          </a:effectRef>
-          <a:fontRef idx="minor">
-            <a:schemeClr val="lt1"/>
-          </a:fontRef>
-        </p:style>
-        <p:txBody>
-          <a:bodyPr rtlCol="0" anchor="ctr"/>
-          <a:lstStyle/>
-          <a:p>
-            <a:pPr algn="ctr"/>
-          </a:p>
-        </p:txBody>
-      </p:sp>
-      <p:sp>
-        <p:nvSpPr>
-          <p:cNvPr id="5" name="Rectangle 4"/>
-          <p:cNvSpPr/>
+        <p:txBody>
+          <a:bodyPr wrap="none">
+            <a:spAutoFit/>
+          </a:bodyPr>
+          <a:lstStyle/>
+          <a:p>
+            <a:pPr algn="ctr">
+              <a:lnSpc>
+                <a:spcPct val="90000"/>
+              </a:lnSpc>
+              <a:defRPr sz="1200">
+                <a:solidFill>
+                  <a:srgbClr val="D2A8FF"/>
+                </a:solidFill>
+                <a:latin typeface="Meslo Nerd Font"/>
+              </a:defRPr>
+            </a:pPr>
+            <a:r>
+              <a:t>═══════════════════════════════</a:t>
+            </a:r>
+          </a:p>
+          <a:p>
+            <a:r>
+              <a:t>     RESULTS &amp; COMPARISON</a:t>
+            </a:r>
+          </a:p>
+          <a:p>
+            <a:r>
+              <a:t>═══════════════════════════════</a:t>
+            </a:r>
+          </a:p>
+        </p:txBody>
+      </p:sp>
+      <p:sp>
+        <p:nvSpPr>
+          <p:cNvPr id="5" name="TextBox 4"/>
+          <p:cNvSpPr txBox="1"/>
           <p:nvPr/>
         </p:nvSpPr>
         <p:spPr>
           <a:xfrm>
-            <a:off x="9098280" y="0"/>
-            <a:ext cx="45720" cy="6858000"/>
+            <a:off x="822960" y="1828800"/>
+            <a:ext cx="7498079" cy="4389120"/>
           </a:xfrm>
           <a:prstGeom prst="rect">
             <a:avLst/>
           </a:prstGeom>
-          <a:solidFill>
-            <a:srgbClr val="30363D"/>
-          </a:solidFill>
-          <a:ln>
-            <a:noFill/>
-          </a:ln>
+          <a:noFill/>
         </p:spPr>
-        <p:style>
-          <a:lnRef idx="1">
-            <a:schemeClr val="accent1"/>
-          </a:lnRef>
-          <a:fillRef idx="3">
-            <a:schemeClr val="accent1"/>
-          </a:fillRef>
-          <a:effectRef idx="2">
-            <a:schemeClr val="accent1"/>
-          </a:effectRef>
-          <a:fontRef idx="minor">
-            <a:schemeClr val="lt1"/>
-          </a:fontRef>
-        </p:style>
-        <p:txBody>
-          <a:bodyPr rtlCol="0" anchor="ctr"/>
-          <a:lstStyle/>
-          <a:p>
-            <a:pPr algn="ctr"/>
+        <p:txBody>
+          <a:bodyPr wrap="none">
+            <a:spAutoFit/>
+          </a:bodyPr>
+          <a:lstStyle/>
+          <a:p>
+            <a:pPr>
+              <a:lnSpc>
+                <a:spcPct val="115000"/>
+              </a:lnSpc>
+              <a:defRPr sz="1000">
+                <a:solidFill>
+                  <a:srgbClr val="C9D1D9"/>
+                </a:solidFill>
+                <a:latin typeface="Meslo Nerd Font"/>
+              </a:defRPr>
+            </a:pPr>
+            <a:r>
+              <a:t>Comparing: DFT (B3LYP) vs ML (MACE-MP + Espaloma)</a:t>
+            </a:r>
+          </a:p>
+          <a:p/>
+          <a:p>
+            <a:r>
+              <a:t> computation_time    | ████████████████████ -95%</a:t>
+            </a:r>
+          </a:p>
+          <a:p>
+            <a:r>
+              <a:t> frequency_accuracy  | ██ +2% MAE</a:t>
+            </a:r>
+          </a:p>
+          <a:p>
+            <a:r>
+              <a:t> intensity_accuracy  | ███ +5% RMSE</a:t>
+            </a:r>
+          </a:p>
+          <a:p>
+            <a:r>
+              <a:t> mode_matching       | ████████████████████ 98%</a:t>
+            </a:r>
+          </a:p>
+          <a:p/>
+          <a:p>
+            <a:r>
+              <a:t> Summary:</a:t>
+            </a:r>
+          </a:p>
+          <a:p>
+            <a:r>
+              <a:t> ──────────────────────────────────────</a:t>
+            </a:r>
+          </a:p>
+          <a:p>
+            <a:r>
+              <a:t>  Metric            DFT        ML</a:t>
+            </a:r>
+          </a:p>
+          <a:p>
+            <a:r>
+              <a:t> ──────────────────────────────────────</a:t>
+            </a:r>
+          </a:p>
+          <a:p>
+            <a:r>
+              <a:t>  Runtime         8.5 hrs    6.2 min</a:t>
+            </a:r>
+          </a:p>
+          <a:p>
+            <a:r>
+              <a:t>  Freq MAE           --      12 cm⁻¹</a:t>
+            </a:r>
+          </a:p>
+          <a:p>
+            <a:r>
+              <a:t>  R²                 --      0.996</a:t>
+            </a:r>
+          </a:p>
+          <a:p>
+            <a:r>
+              <a:t>  Speed Factor       1×       ~100×</a:t>
+            </a:r>
+          </a:p>
+          <a:p>
+            <a:r>
+              <a:t> ──────────────────────────────────────</a:t>
+            </a:r>
+          </a:p>
+          <a:p/>
+          <a:p>
+            <a:r>
+              <a:t> ✓ Validated against DFT baseline</a:t>
+            </a:r>
+          </a:p>
+          <a:p>
+            <a:r>
+              <a:t> ✓ All fundamental modes matched</a:t>
+            </a:r>
           </a:p>
         </p:txBody>
       </p:sp>
@@ -5524,8 +4646,8 @@
         </p:nvSpPr>
         <p:spPr>
           <a:xfrm>
-            <a:off x="45720" y="73152"/>
-            <a:ext cx="9052560" cy="228600"/>
+            <a:off x="0" y="6629400"/>
+            <a:ext cx="9144000" cy="228600"/>
           </a:xfrm>
           <a:prstGeom prst="rect">
             <a:avLst/>
@@ -5567,7 +4689,7 @@
         </p:nvSpPr>
         <p:spPr>
           <a:xfrm>
-            <a:off x="457200" y="100584"/>
+            <a:off x="457200" y="6656832"/>
             <a:ext cx="8229600" cy="182880"/>
           </a:xfrm>
           <a:prstGeom prst="rect">
@@ -5581,399 +4703,12 @@
           </a:bodyPr>
           <a:lstStyle/>
           <a:p>
-            <a:pPr algn="ctr">
-              <a:defRPr sz="800">
-                <a:solidFill>
-                  <a:srgbClr val="8B949E"/>
-                </a:solidFill>
-                <a:latin typeface="Menlo"/>
-              </a:defRPr>
-            </a:pPr>
-            <a:r>
-              <a:t>presentation — mot@rs1-c724</a:t>
-            </a:r>
-          </a:p>
-        </p:txBody>
-      </p:sp>
-      <p:sp>
-        <p:nvSpPr>
-          <p:cNvPr id="8" name="TextBox 7"/>
-          <p:cNvSpPr txBox="1"/>
-          <p:nvPr/>
-        </p:nvSpPr>
-        <p:spPr>
-          <a:xfrm>
-            <a:off x="274320" y="376257312000"/>
-            <a:ext cx="8595360" cy="228600"/>
-          </a:xfrm>
-          <a:prstGeom prst="rect">
-            <a:avLst/>
-          </a:prstGeom>
-          <a:noFill/>
-        </p:spPr>
-        <p:txBody>
-          <a:bodyPr wrap="none">
-            <a:spAutoFit/>
-          </a:bodyPr>
-          <a:lstStyle/>
-          <a:p/>
-          <a:p>
-            <a:r>
-              <a:rPr sz="1100">
-                <a:solidFill>
-                  <a:srgbClr val="8B949E"/>
-                </a:solidFill>
-                <a:latin typeface="Menlo"/>
-              </a:rPr>
-              <a:t>╭─</a:t>
-            </a:r>
-            <a:r>
-              <a:rPr sz="1100" b="1">
-                <a:solidFill>
-                  <a:srgbClr val="56B6C2"/>
-                </a:solidFill>
-                <a:latin typeface="Menlo"/>
-              </a:rPr>
-              <a:t>  mot@rs1-c724 </a:t>
-            </a:r>
-            <a:r>
-              <a:rPr sz="1100">
-                <a:solidFill>
-                  <a:srgbClr val="8B949E"/>
-                </a:solidFill>
-                <a:latin typeface="Menlo"/>
-              </a:rPr>
-              <a:t> </a:t>
-            </a:r>
-            <a:r>
-              <a:rPr sz="1100">
-                <a:solidFill>
-                  <a:srgbClr val="D2A8FF"/>
-                </a:solidFill>
-                <a:latin typeface="Menlo"/>
-              </a:rPr>
-              <a:t> ~/presentation </a:t>
-            </a:r>
-            <a:r>
-              <a:rPr sz="1100">
-                <a:solidFill>
-                  <a:srgbClr val="8B949E"/>
-                </a:solidFill>
-                <a:latin typeface="Menlo"/>
-              </a:rPr>
-              <a:t> </a:t>
-            </a:r>
-            <a:r>
-              <a:rPr sz="1100">
-                <a:solidFill>
-                  <a:srgbClr val="3FB950"/>
-                </a:solidFill>
-                <a:latin typeface="Menlo"/>
-              </a:rPr>
-              <a:t> master </a:t>
-            </a:r>
-            <a:r>
-              <a:rPr sz="1100">
-                <a:solidFill>
-                  <a:srgbClr val="E5C07B"/>
-                </a:solidFill>
-                <a:latin typeface="Menlo"/>
-              </a:rPr>
-              <a:t>⚡</a:t>
-            </a:r>
-          </a:p>
-        </p:txBody>
-      </p:sp>
-      <p:sp>
-        <p:nvSpPr>
-          <p:cNvPr id="9" name="TextBox 8"/>
-          <p:cNvSpPr txBox="1"/>
-          <p:nvPr/>
-        </p:nvSpPr>
-        <p:spPr>
-          <a:xfrm>
-            <a:off x="274320" y="376257540600"/>
-            <a:ext cx="8595360" cy="228600"/>
-          </a:xfrm>
-          <a:prstGeom prst="rect">
-            <a:avLst/>
-          </a:prstGeom>
-          <a:noFill/>
-        </p:spPr>
-        <p:txBody>
-          <a:bodyPr wrap="none">
-            <a:spAutoFit/>
-          </a:bodyPr>
-          <a:lstStyle/>
-          <a:p/>
-          <a:p>
-            <a:r>
-              <a:rPr sz="1100">
-                <a:solidFill>
-                  <a:srgbClr val="8B949E"/>
-                </a:solidFill>
-                <a:latin typeface="Menlo"/>
-              </a:rPr>
-              <a:t>╰─</a:t>
-            </a:r>
-            <a:r>
-              <a:rPr sz="1200" b="1">
-                <a:solidFill>
-                  <a:srgbClr val="3FB950"/>
-                </a:solidFill>
-                <a:latin typeface="Menlo"/>
-              </a:rPr>
-              <a:t>❯ </a:t>
-            </a:r>
-            <a:r>
-              <a:rPr sz="1100">
-                <a:solidFill>
-                  <a:srgbClr val="C9D1D9"/>
-                </a:solidFill>
-                <a:latin typeface="Menlo"/>
-              </a:rPr>
-              <a:t>git diff --stat dft ml</a:t>
-            </a:r>
-          </a:p>
-        </p:txBody>
-      </p:sp>
-      <p:sp>
-        <p:nvSpPr>
-          <p:cNvPr id="10" name="TextBox 9"/>
-          <p:cNvSpPr txBox="1"/>
-          <p:nvPr/>
-        </p:nvSpPr>
-        <p:spPr>
-          <a:xfrm>
-            <a:off x="548640" y="960120"/>
-            <a:ext cx="8046720" cy="548640"/>
-          </a:xfrm>
-          <a:prstGeom prst="rect">
-            <a:avLst/>
-          </a:prstGeom>
-          <a:noFill/>
-        </p:spPr>
-        <p:txBody>
-          <a:bodyPr wrap="none">
-            <a:spAutoFit/>
-          </a:bodyPr>
-          <a:lstStyle/>
-          <a:p>
-            <a:pPr algn="ctr">
-              <a:lnSpc>
-                <a:spcPct val="90000"/>
-              </a:lnSpc>
-              <a:defRPr sz="1200">
-                <a:solidFill>
-                  <a:srgbClr val="D2A8FF"/>
-                </a:solidFill>
-                <a:latin typeface="Menlo"/>
-              </a:defRPr>
-            </a:pPr>
-            <a:r>
-              <a:t>═══════════════════════════════</a:t>
-            </a:r>
-          </a:p>
-          <a:p>
-            <a:r>
-              <a:t>     RESULTS &amp; COMPARISON</a:t>
-            </a:r>
-          </a:p>
-          <a:p>
-            <a:r>
-              <a:t>═══════════════════════════════</a:t>
-            </a:r>
-          </a:p>
-        </p:txBody>
-      </p:sp>
-      <p:sp>
-        <p:nvSpPr>
-          <p:cNvPr id="11" name="TextBox 10"/>
-          <p:cNvSpPr txBox="1"/>
-          <p:nvPr/>
-        </p:nvSpPr>
-        <p:spPr>
-          <a:xfrm>
-            <a:off x="640080" y="1691640"/>
-            <a:ext cx="7863840" cy="4389120"/>
-          </a:xfrm>
-          <a:prstGeom prst="rect">
-            <a:avLst/>
-          </a:prstGeom>
-          <a:noFill/>
-        </p:spPr>
-        <p:txBody>
-          <a:bodyPr wrap="none">
-            <a:spAutoFit/>
-          </a:bodyPr>
-          <a:lstStyle/>
-          <a:p>
-            <a:pPr>
-              <a:lnSpc>
-                <a:spcPct val="115000"/>
-              </a:lnSpc>
-              <a:defRPr sz="1000">
-                <a:solidFill>
-                  <a:srgbClr val="C9D1D9"/>
-                </a:solidFill>
-                <a:latin typeface="Menlo"/>
-              </a:defRPr>
-            </a:pPr>
-            <a:r>
-              <a:t>Comparing: DFT (B3LYP) vs ML (MACE-MP + Espaloma)</a:t>
-            </a:r>
-          </a:p>
-          <a:p/>
-          <a:p>
-            <a:r>
-              <a:t> computation_time    | ████████████████████ -95%</a:t>
-            </a:r>
-          </a:p>
-          <a:p>
-            <a:r>
-              <a:t> frequency_accuracy  | ██ +2% MAE</a:t>
-            </a:r>
-          </a:p>
-          <a:p>
-            <a:r>
-              <a:t> intensity_accuracy  | ███ +5% RMSE</a:t>
-            </a:r>
-          </a:p>
-          <a:p>
-            <a:r>
-              <a:t> mode_matching       | ████████████████████ 98%</a:t>
-            </a:r>
-          </a:p>
-          <a:p/>
-          <a:p>
-            <a:r>
-              <a:t> Summary:</a:t>
-            </a:r>
-          </a:p>
-          <a:p>
-            <a:r>
-              <a:t> ──────────────────────────────────────</a:t>
-            </a:r>
-          </a:p>
-          <a:p>
-            <a:r>
-              <a:t>  Metric            DFT        ML</a:t>
-            </a:r>
-          </a:p>
-          <a:p>
-            <a:r>
-              <a:t> ──────────────────────────────────────</a:t>
-            </a:r>
-          </a:p>
-          <a:p>
-            <a:r>
-              <a:t>  Runtime         8.5 hrs    6.2 min</a:t>
-            </a:r>
-          </a:p>
-          <a:p>
-            <a:r>
-              <a:t>  Freq MAE           --      12 cm⁻¹</a:t>
-            </a:r>
-          </a:p>
-          <a:p>
-            <a:r>
-              <a:t>  R²                 --      0.996</a:t>
-            </a:r>
-          </a:p>
-          <a:p>
-            <a:r>
-              <a:t>  Speed Factor       1×       ~100×</a:t>
-            </a:r>
-          </a:p>
-          <a:p>
-            <a:r>
-              <a:t> ──────────────────────────────────────</a:t>
-            </a:r>
-          </a:p>
-          <a:p/>
-          <a:p>
-            <a:r>
-              <a:t> ✓ Validated against DFT baseline</a:t>
-            </a:r>
-          </a:p>
-          <a:p>
-            <a:r>
-              <a:t> ✓ All fundamental modes matched</a:t>
-            </a:r>
-          </a:p>
-        </p:txBody>
-      </p:sp>
-      <p:sp>
-        <p:nvSpPr>
-          <p:cNvPr id="12" name="Rectangle 11"/>
-          <p:cNvSpPr/>
-          <p:nvPr/>
-        </p:nvSpPr>
-        <p:spPr>
-          <a:xfrm>
-            <a:off x="45720" y="6537960"/>
-            <a:ext cx="9052560" cy="228600"/>
-          </a:xfrm>
-          <a:prstGeom prst="rect">
-            <a:avLst/>
-          </a:prstGeom>
-          <a:solidFill>
-            <a:srgbClr val="161B22"/>
-          </a:solidFill>
-          <a:ln>
-            <a:noFill/>
-          </a:ln>
-        </p:spPr>
-        <p:style>
-          <a:lnRef idx="1">
-            <a:schemeClr val="accent1"/>
-          </a:lnRef>
-          <a:fillRef idx="3">
-            <a:schemeClr val="accent1"/>
-          </a:fillRef>
-          <a:effectRef idx="2">
-            <a:schemeClr val="accent1"/>
-          </a:effectRef>
-          <a:fontRef idx="minor">
-            <a:schemeClr val="lt1"/>
-          </a:fontRef>
-        </p:style>
-        <p:txBody>
-          <a:bodyPr rtlCol="0" anchor="ctr"/>
-          <a:lstStyle/>
-          <a:p>
-            <a:pPr algn="ctr"/>
-          </a:p>
-        </p:txBody>
-      </p:sp>
-      <p:sp>
-        <p:nvSpPr>
-          <p:cNvPr id="13" name="TextBox 12"/>
-          <p:cNvSpPr txBox="1"/>
-          <p:nvPr/>
-        </p:nvSpPr>
-        <p:spPr>
-          <a:xfrm>
-            <a:off x="274320" y="6565392"/>
-            <a:ext cx="8595360" cy="182880"/>
-          </a:xfrm>
-          <a:prstGeom prst="rect">
-            <a:avLst/>
-          </a:prstGeom>
-          <a:noFill/>
-        </p:spPr>
-        <p:txBody>
-          <a:bodyPr wrap="none">
-            <a:spAutoFit/>
-          </a:bodyPr>
-          <a:lstStyle/>
-          <a:p>
             <a:pPr>
               <a:defRPr sz="900">
                 <a:solidFill>
                   <a:srgbClr val="C9D1D9"/>
                 </a:solidFill>
-                <a:latin typeface="Menlo"/>
+                <a:latin typeface="Meslo Nerd Font"/>
               </a:defRPr>
             </a:pPr>
             <a:r>

</xml_diff>

<commit_message>
Revert to simple green prompt and position cursor at end
Changes:
• Replaced P10k multi-line colored prompt with simple green:
  mot@rs1-c724:~/presentation$
• Cursor (█) now positioned at end of prompt line
  - Calculated position based on character count
  - Monospace approximation: 0.06 inches per character
• Cleaner, more traditional terminal look
• Same green color (#3FB950) throughout
• Meslo Nerd Font

Title slide: mot@rs1-c724:~/presentation$ █
Content slides: mot@rs1-c724:~/presentation$ cat motivation.md
</commit_message>
<xml_diff>
--- a/presentation/template_terminal_enhanced.pptx
+++ b/presentation/template_terminal_enhanced.pptx
@@ -3108,7 +3108,7 @@
         <p:spPr>
           <a:xfrm>
             <a:off x="457200" y="418063680000"/>
-            <a:ext cx="8229600" cy="228600"/>
+            <a:ext cx="8229600" cy="274320"/>
           </a:xfrm>
           <a:prstGeom prst="rect">
             <a:avLst/>
@@ -3120,77 +3120,60 @@
             <a:spAutoFit/>
           </a:bodyPr>
           <a:lstStyle/>
-          <a:p/>
-          <a:p>
-            <a:r>
-              <a:rPr sz="1100">
-                <a:solidFill>
-                  <a:srgbClr val="8B949E"/>
+          <a:p>
+            <a:pPr>
+              <a:defRPr sz="1100" b="1">
+                <a:solidFill>
+                  <a:srgbClr val="3FB950"/>
                 </a:solidFill>
                 <a:latin typeface="Meslo Nerd Font"/>
-              </a:rPr>
-              <a:t>╭─</a:t>
-            </a:r>
-            <a:r>
-              <a:rPr sz="1100" b="1">
-                <a:solidFill>
-                  <a:srgbClr val="56B6C2"/>
+              </a:defRPr>
+            </a:pPr>
+            <a:r>
+              <a:t>mot@rs1-c724:~/presentation$ </a:t>
+            </a:r>
+          </a:p>
+        </p:txBody>
+      </p:sp>
+      <p:sp>
+        <p:nvSpPr>
+          <p:cNvPr id="3" name="TextBox 2"/>
+          <p:cNvSpPr txBox="1"/>
+          <p:nvPr/>
+        </p:nvSpPr>
+        <p:spPr>
+          <a:xfrm>
+            <a:off x="2048256" y="475488"/>
+            <a:ext cx="137160" cy="228600"/>
+          </a:xfrm>
+          <a:prstGeom prst="rect">
+            <a:avLst/>
+          </a:prstGeom>
+          <a:noFill/>
+        </p:spPr>
+        <p:txBody>
+          <a:bodyPr wrap="none">
+            <a:spAutoFit/>
+          </a:bodyPr>
+          <a:lstStyle/>
+          <a:p>
+            <a:pPr>
+              <a:defRPr sz="1100">
+                <a:solidFill>
+                  <a:srgbClr val="3FB950"/>
                 </a:solidFill>
                 <a:latin typeface="Meslo Nerd Font"/>
-              </a:rPr>
-              <a:t>  mot@rs1-c724 </a:t>
-            </a:r>
-            <a:r>
-              <a:rPr sz="1100">
-                <a:solidFill>
-                  <a:srgbClr val="8B949E"/>
-                </a:solidFill>
-                <a:latin typeface="Meslo Nerd Font"/>
-              </a:rPr>
-              <a:t> </a:t>
-            </a:r>
-            <a:r>
-              <a:rPr sz="1100">
-                <a:solidFill>
-                  <a:srgbClr val="D2A8FF"/>
-                </a:solidFill>
-                <a:latin typeface="Meslo Nerd Font"/>
-              </a:rPr>
-              <a:t> ~/presentation </a:t>
-            </a:r>
-            <a:r>
-              <a:rPr sz="1100">
-                <a:solidFill>
-                  <a:srgbClr val="8B949E"/>
-                </a:solidFill>
-                <a:latin typeface="Meslo Nerd Font"/>
-              </a:rPr>
-              <a:t> </a:t>
-            </a:r>
-            <a:r>
-              <a:rPr sz="1100">
-                <a:solidFill>
-                  <a:srgbClr val="3FB950"/>
-                </a:solidFill>
-                <a:latin typeface="Meslo Nerd Font"/>
-              </a:rPr>
-              <a:t> master </a:t>
-            </a:r>
-            <a:r>
-              <a:rPr sz="1100">
-                <a:solidFill>
-                  <a:srgbClr val="E5C07B"/>
-                </a:solidFill>
-                <a:latin typeface="Meslo Nerd Font"/>
-              </a:rPr>
-              <a:t>⚡</a:t>
-            </a:r>
-          </a:p>
-        </p:txBody>
-      </p:sp>
-      <p:sp>
-        <p:nvSpPr>
-          <p:cNvPr id="3" name="TextBox 2"/>
+              </a:defRPr>
+            </a:pPr>
+            <a:r>
+              <a:t>█</a:t>
+            </a:r>
+          </a:p>
+        </p:txBody>
+      </p:sp>
+      <p:sp>
+        <p:nvSpPr>
+          <p:cNvPr id="4" name="TextBox 3"/>
           <p:cNvSpPr txBox="1"/>
           <p:nvPr/>
         </p:nvSpPr>
@@ -3249,7 +3232,7 @@
       </p:sp>
       <p:sp>
         <p:nvSpPr>
-          <p:cNvPr id="4" name="TextBox 3"/>
+          <p:cNvPr id="5" name="TextBox 4"/>
           <p:cNvSpPr txBox="1"/>
           <p:nvPr/>
         </p:nvSpPr>
@@ -3285,7 +3268,7 @@
       </p:sp>
       <p:sp>
         <p:nvSpPr>
-          <p:cNvPr id="5" name="TextBox 4"/>
+          <p:cNvPr id="6" name="TextBox 5"/>
           <p:cNvSpPr txBox="1"/>
           <p:nvPr/>
         </p:nvSpPr>
@@ -3356,7 +3339,7 @@
       </p:sp>
       <p:sp>
         <p:nvSpPr>
-          <p:cNvPr id="6" name="TextBox 5"/>
+          <p:cNvPr id="7" name="TextBox 6"/>
           <p:cNvSpPr txBox="1"/>
           <p:nvPr/>
         </p:nvSpPr>
@@ -3386,42 +3369,6 @@
             </a:pPr>
             <a:r>
               <a:t>Your Name  │  Research Group  │  2025-11-15</a:t>
-            </a:r>
-          </a:p>
-        </p:txBody>
-      </p:sp>
-      <p:sp>
-        <p:nvSpPr>
-          <p:cNvPr id="7" name="TextBox 6"/>
-          <p:cNvSpPr txBox="1"/>
-          <p:nvPr/>
-        </p:nvSpPr>
-        <p:spPr>
-          <a:xfrm>
-            <a:off x="4480560" y="6217920"/>
-            <a:ext cx="182880" cy="274320"/>
-          </a:xfrm>
-          <a:prstGeom prst="rect">
-            <a:avLst/>
-          </a:prstGeom>
-          <a:noFill/>
-        </p:spPr>
-        <p:txBody>
-          <a:bodyPr wrap="none">
-            <a:spAutoFit/>
-          </a:bodyPr>
-          <a:lstStyle/>
-          <a:p>
-            <a:pPr>
-              <a:defRPr sz="1400">
-                <a:solidFill>
-                  <a:srgbClr val="3FB950"/>
-                </a:solidFill>
-                <a:latin typeface="Meslo Nerd Font"/>
-              </a:defRPr>
-            </a:pPr>
-            <a:r>
-              <a:t>█</a:t>
             </a:r>
           </a:p>
         </p:txBody>
@@ -3461,7 +3408,7 @@
         <p:spPr>
           <a:xfrm>
             <a:off x="457200" y="418063680000"/>
-            <a:ext cx="8229600" cy="228600"/>
+            <a:ext cx="8229600" cy="274320"/>
           </a:xfrm>
           <a:prstGeom prst="rect">
             <a:avLst/>
@@ -3473,70 +3420,17 @@
             <a:spAutoFit/>
           </a:bodyPr>
           <a:lstStyle/>
-          <a:p/>
-          <a:p>
-            <a:r>
-              <a:rPr sz="1100">
-                <a:solidFill>
-                  <a:srgbClr val="8B949E"/>
+          <a:p>
+            <a:pPr>
+              <a:defRPr sz="1100" b="1">
+                <a:solidFill>
+                  <a:srgbClr val="3FB950"/>
                 </a:solidFill>
                 <a:latin typeface="Meslo Nerd Font"/>
-              </a:rPr>
-              <a:t>╭─</a:t>
-            </a:r>
-            <a:r>
-              <a:rPr sz="1100" b="1">
-                <a:solidFill>
-                  <a:srgbClr val="56B6C2"/>
-                </a:solidFill>
-                <a:latin typeface="Meslo Nerd Font"/>
-              </a:rPr>
-              <a:t>  mot@rs1-c724 </a:t>
-            </a:r>
-            <a:r>
-              <a:rPr sz="1100">
-                <a:solidFill>
-                  <a:srgbClr val="8B949E"/>
-                </a:solidFill>
-                <a:latin typeface="Meslo Nerd Font"/>
-              </a:rPr>
-              <a:t> </a:t>
-            </a:r>
-            <a:r>
-              <a:rPr sz="1100">
-                <a:solidFill>
-                  <a:srgbClr val="D2A8FF"/>
-                </a:solidFill>
-                <a:latin typeface="Meslo Nerd Font"/>
-              </a:rPr>
-              <a:t> ~/presentation </a:t>
-            </a:r>
-            <a:r>
-              <a:rPr sz="1100">
-                <a:solidFill>
-                  <a:srgbClr val="8B949E"/>
-                </a:solidFill>
-                <a:latin typeface="Meslo Nerd Font"/>
-              </a:rPr>
-              <a:t> </a:t>
-            </a:r>
-            <a:r>
-              <a:rPr sz="1100">
-                <a:solidFill>
-                  <a:srgbClr val="3FB950"/>
-                </a:solidFill>
-                <a:latin typeface="Meslo Nerd Font"/>
-              </a:rPr>
-              <a:t> master </a:t>
-            </a:r>
-            <a:r>
-              <a:rPr sz="1100">
-                <a:solidFill>
-                  <a:srgbClr val="E5C07B"/>
-                </a:solidFill>
-                <a:latin typeface="Meslo Nerd Font"/>
-              </a:rPr>
-              <a:t>⚡</a:t>
+              </a:defRPr>
+            </a:pPr>
+            <a:r>
+              <a:t>mot@rs1-c724:~/presentation$ cat motivation.md</a:t>
             </a:r>
           </a:p>
         </p:txBody>
@@ -3544,59 +3438,6 @@
       <p:sp>
         <p:nvSpPr>
           <p:cNvPr id="3" name="TextBox 2"/>
-          <p:cNvSpPr txBox="1"/>
-          <p:nvPr/>
-        </p:nvSpPr>
-        <p:spPr>
-          <a:xfrm>
-            <a:off x="457200" y="418063908600"/>
-            <a:ext cx="8229600" cy="228600"/>
-          </a:xfrm>
-          <a:prstGeom prst="rect">
-            <a:avLst/>
-          </a:prstGeom>
-          <a:noFill/>
-        </p:spPr>
-        <p:txBody>
-          <a:bodyPr wrap="none">
-            <a:spAutoFit/>
-          </a:bodyPr>
-          <a:lstStyle/>
-          <a:p/>
-          <a:p>
-            <a:r>
-              <a:rPr sz="1100">
-                <a:solidFill>
-                  <a:srgbClr val="8B949E"/>
-                </a:solidFill>
-                <a:latin typeface="Meslo Nerd Font"/>
-              </a:rPr>
-              <a:t>╰─</a:t>
-            </a:r>
-            <a:r>
-              <a:rPr sz="1200" b="1">
-                <a:solidFill>
-                  <a:srgbClr val="3FB950"/>
-                </a:solidFill>
-                <a:latin typeface="Meslo Nerd Font"/>
-              </a:rPr>
-              <a:t>❯ </a:t>
-            </a:r>
-            <a:r>
-              <a:rPr sz="1100">
-                <a:solidFill>
-                  <a:srgbClr val="C9D1D9"/>
-                </a:solidFill>
-                <a:latin typeface="Meslo Nerd Font"/>
-              </a:rPr>
-              <a:t>cat motivation.md</a:t>
-            </a:r>
-          </a:p>
-        </p:txBody>
-      </p:sp>
-      <p:sp>
-        <p:nvSpPr>
-          <p:cNvPr id="4" name="TextBox 3"/>
           <p:cNvSpPr txBox="1"/>
           <p:nvPr/>
         </p:nvSpPr>
@@ -3645,7 +3486,7 @@
       </p:sp>
       <p:sp>
         <p:nvSpPr>
-          <p:cNvPr id="5" name="TextBox 4"/>
+          <p:cNvPr id="4" name="TextBox 3"/>
           <p:cNvSpPr txBox="1"/>
           <p:nvPr/>
         </p:nvSpPr>
@@ -3831,7 +3672,7 @@
       </p:sp>
       <p:sp>
         <p:nvSpPr>
-          <p:cNvPr id="6" name="Rectangle 5"/>
+          <p:cNvPr id="5" name="Rectangle 4"/>
           <p:cNvSpPr/>
           <p:nvPr/>
         </p:nvSpPr>
@@ -3874,7 +3715,7 @@
       </p:sp>
       <p:sp>
         <p:nvSpPr>
-          <p:cNvPr id="7" name="TextBox 6"/>
+          <p:cNvPr id="6" name="TextBox 5"/>
           <p:cNvSpPr txBox="1"/>
           <p:nvPr/>
         </p:nvSpPr>
@@ -3943,7 +3784,7 @@
         <p:spPr>
           <a:xfrm>
             <a:off x="457200" y="418063680000"/>
-            <a:ext cx="8229600" cy="228600"/>
+            <a:ext cx="8229600" cy="274320"/>
           </a:xfrm>
           <a:prstGeom prst="rect">
             <a:avLst/>
@@ -3955,70 +3796,17 @@
             <a:spAutoFit/>
           </a:bodyPr>
           <a:lstStyle/>
-          <a:p/>
-          <a:p>
-            <a:r>
-              <a:rPr sz="1100">
-                <a:solidFill>
-                  <a:srgbClr val="8B949E"/>
+          <a:p>
+            <a:pPr>
+              <a:defRPr sz="1100" b="1">
+                <a:solidFill>
+                  <a:srgbClr val="3FB950"/>
                 </a:solidFill>
                 <a:latin typeface="Meslo Nerd Font"/>
-              </a:rPr>
-              <a:t>╭─</a:t>
-            </a:r>
-            <a:r>
-              <a:rPr sz="1100" b="1">
-                <a:solidFill>
-                  <a:srgbClr val="56B6C2"/>
-                </a:solidFill>
-                <a:latin typeface="Meslo Nerd Font"/>
-              </a:rPr>
-              <a:t>  mot@rs1-c724 </a:t>
-            </a:r>
-            <a:r>
-              <a:rPr sz="1100">
-                <a:solidFill>
-                  <a:srgbClr val="8B949E"/>
-                </a:solidFill>
-                <a:latin typeface="Meslo Nerd Font"/>
-              </a:rPr>
-              <a:t> </a:t>
-            </a:r>
-            <a:r>
-              <a:rPr sz="1100">
-                <a:solidFill>
-                  <a:srgbClr val="D2A8FF"/>
-                </a:solidFill>
-                <a:latin typeface="Meslo Nerd Font"/>
-              </a:rPr>
-              <a:t> ~/presentation </a:t>
-            </a:r>
-            <a:r>
-              <a:rPr sz="1100">
-                <a:solidFill>
-                  <a:srgbClr val="8B949E"/>
-                </a:solidFill>
-                <a:latin typeface="Meslo Nerd Font"/>
-              </a:rPr>
-              <a:t> </a:t>
-            </a:r>
-            <a:r>
-              <a:rPr sz="1100">
-                <a:solidFill>
-                  <a:srgbClr val="3FB950"/>
-                </a:solidFill>
-                <a:latin typeface="Meslo Nerd Font"/>
-              </a:rPr>
-              <a:t> master </a:t>
-            </a:r>
-            <a:r>
-              <a:rPr sz="1100">
-                <a:solidFill>
-                  <a:srgbClr val="E5C07B"/>
-                </a:solidFill>
-                <a:latin typeface="Meslo Nerd Font"/>
-              </a:rPr>
-              <a:t>⚡</a:t>
+              </a:defRPr>
+            </a:pPr>
+            <a:r>
+              <a:t>mot@rs1-c724:~/presentation$ ls -la architecture/</a:t>
             </a:r>
           </a:p>
         </p:txBody>
@@ -4026,59 +3814,6 @@
       <p:sp>
         <p:nvSpPr>
           <p:cNvPr id="3" name="TextBox 2"/>
-          <p:cNvSpPr txBox="1"/>
-          <p:nvPr/>
-        </p:nvSpPr>
-        <p:spPr>
-          <a:xfrm>
-            <a:off x="457200" y="418063908600"/>
-            <a:ext cx="8229600" cy="228600"/>
-          </a:xfrm>
-          <a:prstGeom prst="rect">
-            <a:avLst/>
-          </a:prstGeom>
-          <a:noFill/>
-        </p:spPr>
-        <p:txBody>
-          <a:bodyPr wrap="none">
-            <a:spAutoFit/>
-          </a:bodyPr>
-          <a:lstStyle/>
-          <a:p/>
-          <a:p>
-            <a:r>
-              <a:rPr sz="1100">
-                <a:solidFill>
-                  <a:srgbClr val="8B949E"/>
-                </a:solidFill>
-                <a:latin typeface="Meslo Nerd Font"/>
-              </a:rPr>
-              <a:t>╰─</a:t>
-            </a:r>
-            <a:r>
-              <a:rPr sz="1200" b="1">
-                <a:solidFill>
-                  <a:srgbClr val="3FB950"/>
-                </a:solidFill>
-                <a:latin typeface="Meslo Nerd Font"/>
-              </a:rPr>
-              <a:t>❯ </a:t>
-            </a:r>
-            <a:r>
-              <a:rPr sz="1100">
-                <a:solidFill>
-                  <a:srgbClr val="C9D1D9"/>
-                </a:solidFill>
-                <a:latin typeface="Meslo Nerd Font"/>
-              </a:rPr>
-              <a:t>ls -la architecture/</a:t>
-            </a:r>
-          </a:p>
-        </p:txBody>
-      </p:sp>
-      <p:sp>
-        <p:nvSpPr>
-          <p:cNvPr id="4" name="TextBox 3"/>
           <p:cNvSpPr txBox="1"/>
           <p:nvPr/>
         </p:nvSpPr>
@@ -4127,7 +3862,7 @@
       </p:sp>
       <p:sp>
         <p:nvSpPr>
-          <p:cNvPr id="5" name="TextBox 4"/>
+          <p:cNvPr id="4" name="TextBox 3"/>
           <p:cNvSpPr txBox="1"/>
           <p:nvPr/>
         </p:nvSpPr>
@@ -4227,7 +3962,7 @@
       </p:sp>
       <p:sp>
         <p:nvSpPr>
-          <p:cNvPr id="6" name="Rectangle 5"/>
+          <p:cNvPr id="5" name="Rectangle 4"/>
           <p:cNvSpPr/>
           <p:nvPr/>
         </p:nvSpPr>
@@ -4270,7 +4005,7 @@
       </p:sp>
       <p:sp>
         <p:nvSpPr>
-          <p:cNvPr id="7" name="TextBox 6"/>
+          <p:cNvPr id="6" name="TextBox 5"/>
           <p:cNvSpPr txBox="1"/>
           <p:nvPr/>
         </p:nvSpPr>
@@ -4339,7 +4074,7 @@
         <p:spPr>
           <a:xfrm>
             <a:off x="457200" y="418063680000"/>
-            <a:ext cx="8229600" cy="228600"/>
+            <a:ext cx="8229600" cy="274320"/>
           </a:xfrm>
           <a:prstGeom prst="rect">
             <a:avLst/>
@@ -4351,70 +4086,17 @@
             <a:spAutoFit/>
           </a:bodyPr>
           <a:lstStyle/>
-          <a:p/>
-          <a:p>
-            <a:r>
-              <a:rPr sz="1100">
-                <a:solidFill>
-                  <a:srgbClr val="8B949E"/>
+          <a:p>
+            <a:pPr>
+              <a:defRPr sz="1100" b="1">
+                <a:solidFill>
+                  <a:srgbClr val="3FB950"/>
                 </a:solidFill>
                 <a:latin typeface="Meslo Nerd Font"/>
-              </a:rPr>
-              <a:t>╭─</a:t>
-            </a:r>
-            <a:r>
-              <a:rPr sz="1100" b="1">
-                <a:solidFill>
-                  <a:srgbClr val="56B6C2"/>
-                </a:solidFill>
-                <a:latin typeface="Meslo Nerd Font"/>
-              </a:rPr>
-              <a:t>  mot@rs1-c724 </a:t>
-            </a:r>
-            <a:r>
-              <a:rPr sz="1100">
-                <a:solidFill>
-                  <a:srgbClr val="8B949E"/>
-                </a:solidFill>
-                <a:latin typeface="Meslo Nerd Font"/>
-              </a:rPr>
-              <a:t> </a:t>
-            </a:r>
-            <a:r>
-              <a:rPr sz="1100">
-                <a:solidFill>
-                  <a:srgbClr val="D2A8FF"/>
-                </a:solidFill>
-                <a:latin typeface="Meslo Nerd Font"/>
-              </a:rPr>
-              <a:t> ~/presentation </a:t>
-            </a:r>
-            <a:r>
-              <a:rPr sz="1100">
-                <a:solidFill>
-                  <a:srgbClr val="8B949E"/>
-                </a:solidFill>
-                <a:latin typeface="Meslo Nerd Font"/>
-              </a:rPr>
-              <a:t> </a:t>
-            </a:r>
-            <a:r>
-              <a:rPr sz="1100">
-                <a:solidFill>
-                  <a:srgbClr val="3FB950"/>
-                </a:solidFill>
-                <a:latin typeface="Meslo Nerd Font"/>
-              </a:rPr>
-              <a:t> master </a:t>
-            </a:r>
-            <a:r>
-              <a:rPr sz="1100">
-                <a:solidFill>
-                  <a:srgbClr val="E5C07B"/>
-                </a:solidFill>
-                <a:latin typeface="Meslo Nerd Font"/>
-              </a:rPr>
-              <a:t>⚡</a:t>
+              </a:defRPr>
+            </a:pPr>
+            <a:r>
+              <a:t>mot@rs1-c724:~/presentation$ git diff --stat dft ml</a:t>
             </a:r>
           </a:p>
         </p:txBody>
@@ -4422,59 +4104,6 @@
       <p:sp>
         <p:nvSpPr>
           <p:cNvPr id="3" name="TextBox 2"/>
-          <p:cNvSpPr txBox="1"/>
-          <p:nvPr/>
-        </p:nvSpPr>
-        <p:spPr>
-          <a:xfrm>
-            <a:off x="457200" y="418063908600"/>
-            <a:ext cx="8229600" cy="228600"/>
-          </a:xfrm>
-          <a:prstGeom prst="rect">
-            <a:avLst/>
-          </a:prstGeom>
-          <a:noFill/>
-        </p:spPr>
-        <p:txBody>
-          <a:bodyPr wrap="none">
-            <a:spAutoFit/>
-          </a:bodyPr>
-          <a:lstStyle/>
-          <a:p/>
-          <a:p>
-            <a:r>
-              <a:rPr sz="1100">
-                <a:solidFill>
-                  <a:srgbClr val="8B949E"/>
-                </a:solidFill>
-                <a:latin typeface="Meslo Nerd Font"/>
-              </a:rPr>
-              <a:t>╰─</a:t>
-            </a:r>
-            <a:r>
-              <a:rPr sz="1200" b="1">
-                <a:solidFill>
-                  <a:srgbClr val="3FB950"/>
-                </a:solidFill>
-                <a:latin typeface="Meslo Nerd Font"/>
-              </a:rPr>
-              <a:t>❯ </a:t>
-            </a:r>
-            <a:r>
-              <a:rPr sz="1100">
-                <a:solidFill>
-                  <a:srgbClr val="C9D1D9"/>
-                </a:solidFill>
-                <a:latin typeface="Meslo Nerd Font"/>
-              </a:rPr>
-              <a:t>git diff --stat dft ml</a:t>
-            </a:r>
-          </a:p>
-        </p:txBody>
-      </p:sp>
-      <p:sp>
-        <p:nvSpPr>
-          <p:cNvPr id="4" name="TextBox 3"/>
           <p:cNvSpPr txBox="1"/>
           <p:nvPr/>
         </p:nvSpPr>
@@ -4523,7 +4152,7 @@
       </p:sp>
       <p:sp>
         <p:nvSpPr>
-          <p:cNvPr id="5" name="TextBox 4"/>
+          <p:cNvPr id="4" name="TextBox 3"/>
           <p:cNvSpPr txBox="1"/>
           <p:nvPr/>
         </p:nvSpPr>
@@ -4640,7 +4269,7 @@
       </p:sp>
       <p:sp>
         <p:nvSpPr>
-          <p:cNvPr id="6" name="Rectangle 5"/>
+          <p:cNvPr id="5" name="Rectangle 4"/>
           <p:cNvSpPr/>
           <p:nvPr/>
         </p:nvSpPr>
@@ -4683,7 +4312,7 @@
       </p:sp>
       <p:sp>
         <p:nvSpPr>
-          <p:cNvPr id="7" name="TextBox 6"/>
+          <p:cNvPr id="6" name="TextBox 5"/>
           <p:cNvSpPr txBox="1"/>
           <p:nvPr/>
         </p:nvSpPr>

</xml_diff>